<commit_message>
fix: Noite 6 - roteadores de fabrica (Wi-Fi pela etiqueta, senha de admin criada no Bloco 5)
Co-Authored-By: Claude Opus 5.5 <noreply@anthropic.com>
Claude-Session: https://claude.ai/code/session_014d2FCU4ZD84rtzS7r1bjwe
</commit_message>
<xml_diff>
--- a/Aula - Redes 6 - Endereco na rede.pptx
+++ b/Aula - Redes 6 - Endereco na rede.pptx
@@ -3583,7 +3583,7 @@
                   <a:srgbClr val="1A1A1A"/>
                 </a:solidFill>
               </a:rPr>
-              <a:t>2.  Conecte no Wi-Fi da sua equipe ("sem internet"? conecte assim mesmo)</a:t>
+              <a:t>2.  Conecte no Wi-Fi do roteador da equipe — nome e senha estão na etiqueta</a:t>
             </a:r>
           </a:p>
           <a:p>
@@ -5013,7 +5013,7 @@
                   <a:srgbClr val="1A1A1A"/>
                 </a:solidFill>
               </a:rPr>
-              <a:t>2.  Senha de administrador: o professor passa</a:t>
+              <a:t>2.  Primeiro acesso: crie a senha de administrador que o professor ditar</a:t>
             </a:r>
           </a:p>
           <a:p>
@@ -5024,7 +5024,7 @@
                   <a:srgbClr val="1A1A1A"/>
                 </a:solidFill>
               </a:rPr>
-              <a:t>3.  Ache a lista de aparelhos (caminho na fita do roteador)</a:t>
+              <a:t>3.  Assistente de configuração? Pule. Ache a lista de aparelhos</a:t>
             </a:r>
           </a:p>
           <a:p>
@@ -5080,7 +5080,7 @@
                   <a:srgbClr val="C5362B"/>
                 </a:solidFill>
               </a:rPr>
-              <a:t>Hoje NÃO se muda nada no painel. Só olhar.</a:t>
+              <a:t>Fora a senha de administrador, hoje NÃO se muda nada. Só olhar.</a:t>
             </a:r>
           </a:p>
         </p:txBody>

</xml_diff>

<commit_message>
feat: Noite 6 - troca role-play e duelo por porteiro vivo (DHCP encenado) e cartaz da rede
Co-Authored-By: Claude Opus 5.5 <noreply@anthropic.com>
Claude-Session: https://claude.ai/code/session_014d2FCU4ZD84rtzS7r1bjwe
</commit_message>
<xml_diff>
--- a/Aula - Redes 6 - Endereco na rede.pptx
+++ b/Aula - Redes 6 - Endereco na rede.pptx
@@ -33,6 +33,8 @@
     <p:sldId id="281" r:id="rId32"/>
     <p:sldId id="282" r:id="rId33"/>
     <p:sldId id="283" r:id="rId34"/>
+    <p:sldId id="284" r:id="rId35"/>
+    <p:sldId id="285" r:id="rId36"/>
   </p:sldIdLst>
   <p:sldSz cx="12191695" cy="6858000" type="screen4x3"/>
   <p:notesSz cx="6858000" cy="9144000"/>
@@ -4696,8 +4698,8 @@
         </p:nvSpPr>
         <p:spPr>
           <a:xfrm>
-            <a:off x="640080" y="1463040"/>
-            <a:ext cx="10881360" cy="457200"/>
+            <a:off x="640080" y="365760"/>
+            <a:ext cx="10881360" cy="320040"/>
           </a:xfrm>
           <a:prstGeom prst="rect">
             <a:avLst/>
@@ -4710,14 +4712,14 @@
           </a:bodyPr>
           <a:lstStyle/>
           <a:p>
-            <a:pPr algn="ctr"/>
-            <a:r>
-              <a:rPr sz="1600" b="1" i="0">
+            <a:pPr algn="l"/>
+            <a:r>
+              <a:rPr sz="1300" b="1" i="0">
                 <a:solidFill>
                   <a:srgbClr val="E88B1A"/>
                 </a:solidFill>
               </a:rPr>
-              <a:t/>
+              <a:t>PRÁTICA · 25 MIN</a:t>
             </a:r>
           </a:p>
         </p:txBody>
@@ -4730,8 +4732,8 @@
         </p:nvSpPr>
         <p:spPr>
           <a:xfrm>
-            <a:off x="822960" y="2194560"/>
-            <a:ext cx="10515600" cy="2743200"/>
+            <a:off x="640080" y="685800"/>
+            <a:ext cx="10881360" cy="822960"/>
           </a:xfrm>
           <a:prstGeom prst="rect">
             <a:avLst/>
@@ -4744,32 +4746,176 @@
           </a:bodyPr>
           <a:lstStyle/>
           <a:p>
+            <a:pPr algn="l"/>
+            <a:r>
+              <a:rPr sz="3400" b="1" i="0">
+                <a:solidFill>
+                  <a:srgbClr val="0B5C5C"/>
+                </a:solidFill>
+              </a:rPr>
+              <a:t>O porteiro vivo</a:t>
+            </a:r>
+          </a:p>
+        </p:txBody>
+      </p:sp>
+      <p:sp>
+        <p:nvSpPr>
+          <p:cNvPr id="5" name="Rectangle 4"/>
+          <p:cNvSpPr/>
+          <p:nvPr/>
+        </p:nvSpPr>
+        <p:spPr>
+          <a:xfrm>
+            <a:off x="640080" y="1554480"/>
+            <a:ext cx="10881360" cy="54864"/>
+          </a:xfrm>
+          <a:prstGeom prst="rect">
+            <a:avLst/>
+          </a:prstGeom>
+          <a:solidFill>
+            <a:srgbClr val="0B5C5C"/>
+          </a:solidFill>
+          <a:ln>
+            <a:noFill/>
+          </a:ln>
+        </p:spPr>
+        <p:style>
+          <a:lnRef idx="1">
+            <a:schemeClr val="accent1"/>
+          </a:lnRef>
+          <a:fillRef idx="3">
+            <a:schemeClr val="accent1"/>
+          </a:fillRef>
+          <a:effectRef idx="2">
+            <a:schemeClr val="accent1"/>
+          </a:effectRef>
+          <a:fontRef idx="minor">
+            <a:schemeClr val="lt1"/>
+          </a:fontRef>
+        </p:style>
+        <p:txBody>
+          <a:bodyPr rtlCol="0" anchor="ctr"/>
+          <a:lstStyle/>
+          <a:p>
             <a:pPr algn="ctr"/>
-            <a:r>
-              <a:rPr sz="3600" b="1" i="0">
+          </a:p>
+        </p:txBody>
+      </p:sp>
+      <p:sp>
+        <p:nvSpPr>
+          <p:cNvPr id="6" name="TextBox 5"/>
+          <p:cNvSpPr txBox="1"/>
+          <p:nvPr/>
+        </p:nvSpPr>
+        <p:spPr>
+          <a:xfrm>
+            <a:off x="640080" y="2560320"/>
+            <a:ext cx="10881360" cy="3474720"/>
+          </a:xfrm>
+          <a:prstGeom prst="rect">
+            <a:avLst/>
+          </a:prstGeom>
+          <a:noFill/>
+        </p:spPr>
+        <p:txBody>
+          <a:bodyPr wrap="square" lIns="0" rIns="0" tIns="0" bIns="0" anchor="t">
+            <a:spAutoFit/>
+          </a:bodyPr>
+          <a:lstStyle/>
+          <a:p>
+            <a:pPr algn="l"/>
+            <a:r>
+              <a:rPr sz="2000" b="0" i="0">
                 <a:solidFill>
                   <a:srgbClr val="1A1A1A"/>
                 </a:solidFill>
               </a:rPr>
-              <a:t>INTERVALO</a:t>
-            </a:r>
-          </a:p>
+              <a:t>Um é o porteiro (o roteador). Os outros recebem um cartão de MAC.</a:t>
+            </a:r>
+          </a:p>
+          <a:p>
+            <a:pPr algn="l"/>
+            <a:r>
+              <a:rPr sz="2000" b="0" i="0">
+                <a:solidFill>
+                  <a:srgbClr val="1A1A1A"/>
+                </a:solidFill>
+              </a:rPr>
+              <a:t/>
+            </a:r>
+          </a:p>
+          <a:p>
+            <a:pPr algn="l"/>
+            <a:r>
+              <a:rPr sz="2000" b="0" i="0">
+                <a:solidFill>
+                  <a:srgbClr val="1A1A1A"/>
+                </a:solidFill>
+              </a:rPr>
+              <a:t>Chegou?  "Meu MAC é ___. Alguém me dá um endereço?"</a:t>
+            </a:r>
+          </a:p>
+          <a:p>
+            <a:pPr algn="l"/>
+            <a:r>
+              <a:rPr sz="2000" b="0" i="0">
+                <a:solidFill>
+                  <a:srgbClr val="1A1A1A"/>
+                </a:solidFill>
+              </a:rPr>
+              <a:t>O porteiro anota no Livro e escreve no seu crachá:</a:t>
+            </a:r>
+          </a:p>
+          <a:p>
+            <a:pPr algn="l"/>
+            <a:r>
+              <a:rPr sz="2000" b="0" i="0">
+                <a:solidFill>
+                  <a:srgbClr val="1A1A1A"/>
+                </a:solidFill>
+              </a:rPr>
+              <a:t>     o seu IP   +   portaria 192.168.0.1</a:t>
+            </a:r>
+          </a:p>
+        </p:txBody>
+      </p:sp>
+      <p:sp>
+        <p:nvSpPr>
+          <p:cNvPr id="7" name="TextBox 6"/>
+          <p:cNvSpPr txBox="1"/>
+          <p:nvPr/>
+        </p:nvSpPr>
+        <p:spPr>
+          <a:xfrm>
+            <a:off x="640080" y="5852160"/>
+            <a:ext cx="10881360" cy="457200"/>
+          </a:xfrm>
+          <a:prstGeom prst="rect">
+            <a:avLst/>
+          </a:prstGeom>
+          <a:noFill/>
+        </p:spPr>
+        <p:txBody>
+          <a:bodyPr wrap="square" lIns="0" rIns="0" tIns="0" bIns="0" anchor="t">
+            <a:spAutoFit/>
+          </a:bodyPr>
+          <a:lstStyle/>
           <a:p>
             <a:pPr algn="ctr"/>
             <a:r>
-              <a:rPr sz="3600" b="1" i="0">
-                <a:solidFill>
-                  <a:srgbClr val="1A1A1A"/>
-                </a:solidFill>
-              </a:rPr>
-              <a:t>15 minutos</a:t>
-            </a:r>
-          </a:p>
-        </p:txBody>
-      </p:sp>
-      <p:sp>
-        <p:nvSpPr>
-          <p:cNvPr id="5" name="TextBox 4"/>
+              <a:rPr sz="1600" b="0" i="1">
+                <a:solidFill>
+                  <a:srgbClr val="E88B1A"/>
+                </a:solidFill>
+              </a:rPr>
+              <a:t>Sete rodadas. Cada uma é um problema de verdade.</a:t>
+            </a:r>
+          </a:p>
+        </p:txBody>
+      </p:sp>
+      <p:sp>
+        <p:nvSpPr>
+          <p:cNvPr id="8" name="TextBox 7"/>
           <p:cNvSpPr txBox="1"/>
           <p:nvPr/>
         </p:nvSpPr>
@@ -4891,7 +5037,7 @@
                   <a:srgbClr val="E88B1A"/>
                 </a:solidFill>
               </a:rPr>
-              <a:t>PRÁTICA · 35 MIN</a:t>
+              <a:t>AS RODADAS</a:t>
             </a:r>
           </a:p>
         </p:txBody>
@@ -4925,7 +5071,7 @@
                   <a:srgbClr val="0B5C5C"/>
                 </a:solidFill>
               </a:rPr>
-              <a:t>Quem está na rede?</a:t>
+              <a:t>O que cada uma mostra</a:t>
             </a:r>
           </a:p>
         </p:txBody>
@@ -4973,121 +5119,331 @@
           </a:p>
         </p:txBody>
       </p:sp>
-      <p:sp>
-        <p:nvSpPr>
-          <p:cNvPr id="6" name="TextBox 5"/>
-          <p:cNvSpPr txBox="1"/>
-          <p:nvPr/>
-        </p:nvSpPr>
-        <p:spPr>
-          <a:xfrm>
-            <a:off x="640080" y="2560320"/>
-            <a:ext cx="10881360" cy="3474720"/>
-          </a:xfrm>
-          <a:prstGeom prst="rect">
-            <a:avLst/>
-          </a:prstGeom>
-          <a:noFill/>
-        </p:spPr>
-        <p:txBody>
-          <a:bodyPr wrap="square" lIns="0" rIns="0" tIns="0" bIns="0" anchor="t">
-            <a:spAutoFit/>
-          </a:bodyPr>
-          <a:lstStyle/>
-          <a:p>
-            <a:pPr algn="l"/>
-            <a:r>
-              <a:rPr sz="2000" b="0" i="0">
-                <a:solidFill>
-                  <a:srgbClr val="1A1A1A"/>
-                </a:solidFill>
-              </a:rPr>
-              <a:t>1.  No navegador do celular: 192.168.0.1</a:t>
-            </a:r>
-          </a:p>
-          <a:p>
-            <a:pPr algn="l"/>
-            <a:r>
-              <a:rPr sz="2000" b="0" i="0">
-                <a:solidFill>
-                  <a:srgbClr val="1A1A1A"/>
-                </a:solidFill>
-              </a:rPr>
-              <a:t>2.  Primeiro acesso: crie a senha de administrador que o professor ditar</a:t>
-            </a:r>
-          </a:p>
-          <a:p>
-            <a:pPr algn="l"/>
-            <a:r>
-              <a:rPr sz="2000" b="0" i="0">
-                <a:solidFill>
-                  <a:srgbClr val="1A1A1A"/>
-                </a:solidFill>
-              </a:rPr>
-              <a:t>3.  Assistente de configuração? Pule. Ache a lista de aparelhos</a:t>
-            </a:r>
-          </a:p>
-          <a:p>
-            <a:pPr algn="l"/>
-            <a:r>
-              <a:rPr sz="2000" b="0" i="0">
-                <a:solidFill>
-                  <a:srgbClr val="1A1A1A"/>
-                </a:solidFill>
-              </a:rPr>
-              <a:t>4.  Anote nome, IP e MAC de cada um — e de quem é</a:t>
-            </a:r>
-          </a:p>
-          <a:p>
-            <a:pPr algn="l"/>
-            <a:r>
-              <a:rPr sz="2000" b="0" i="0">
-                <a:solidFill>
-                  <a:srgbClr val="1A1A1A"/>
-                </a:solidFill>
-              </a:rPr>
-              <a:t>5.  O MAC bate com o que você anotou?</a:t>
-            </a:r>
-          </a:p>
-        </p:txBody>
-      </p:sp>
+      <p:graphicFrame>
+        <p:nvGraphicFramePr>
+          <p:cNvPr id="6" name="Table 5"/>
+          <p:cNvGraphicFramePr>
+            <a:graphicFrameLocks noGrp="1"/>
+          </p:cNvGraphicFramePr>
+          <p:nvPr/>
+        </p:nvGraphicFramePr>
+        <p:xfrm>
+          <a:off x="640080" y="2377440"/>
+          <a:ext cx="10881360" cy="3657600"/>
+        </p:xfrm>
+        <a:graphic>
+          <a:graphicData uri="http://schemas.openxmlformats.org/drawingml/2006/table">
+            <a:tbl>
+              <a:tblPr firstRow="1" bandRow="1">
+                <a:tableStyleId>{5C22544A-7EE6-4342-B048-85BDC9FD1C3A}</a:tableStyleId>
+              </a:tblPr>
+              <a:tblGrid>
+                <a:gridCol w="3291840"/>
+                <a:gridCol w="7589520"/>
+              </a:tblGrid>
+              <a:tr h="457200">
+                <a:tc>
+                  <a:txBody>
+                    <a:bodyPr/>
+                    <a:lstStyle/>
+                    <a:p>
+                      <a:r>
+                        <a:rPr sz="1500" b="1">
+                          <a:solidFill>
+                            <a:srgbClr val="FFFFFF"/>
+                          </a:solidFill>
+                        </a:rPr>
+                        <a:t>Rodada</a:t>
+                      </a:r>
+                    </a:p>
+                  </a:txBody>
+                  <a:tcPr>
+                    <a:solidFill>
+                      <a:srgbClr val="0B5C5C"/>
+                    </a:solidFill>
+                  </a:tcPr>
+                </a:tc>
+                <a:tc>
+                  <a:txBody>
+                    <a:bodyPr/>
+                    <a:lstStyle/>
+                    <a:p>
+                      <a:r>
+                        <a:rPr sz="1500" b="1">
+                          <a:solidFill>
+                            <a:srgbClr val="FFFFFF"/>
+                          </a:solidFill>
+                        </a:rPr>
+                        <a:t>Na vida real</a:t>
+                      </a:r>
+                    </a:p>
+                  </a:txBody>
+                  <a:tcPr>
+                    <a:solidFill>
+                      <a:srgbClr val="0B5C5C"/>
+                    </a:solidFill>
+                  </a:tcPr>
+                </a:tc>
+              </a:tr>
+              <a:tr h="457200">
+                <a:tc>
+                  <a:txBody>
+                    <a:bodyPr/>
+                    <a:lstStyle/>
+                    <a:p>
+                      <a:r>
+                        <a:rPr sz="1500" b="0">
+                          <a:solidFill>
+                            <a:srgbClr val="1A1A1A"/>
+                          </a:solidFill>
+                        </a:rPr>
+                        <a:t>1. Chegada</a:t>
+                      </a:r>
+                    </a:p>
+                  </a:txBody>
+                  <a:tcPr/>
+                </a:tc>
+                <a:tc>
+                  <a:txBody>
+                    <a:bodyPr/>
+                    <a:lstStyle/>
+                    <a:p>
+                      <a:r>
+                        <a:rPr sz="1500" b="0">
+                          <a:solidFill>
+                            <a:srgbClr val="1A1A1A"/>
+                          </a:solidFill>
+                        </a:rPr>
+                        <a:t>O roteador dá IP e anota quem recebeu</a:t>
+                      </a:r>
+                    </a:p>
+                  </a:txBody>
+                  <a:tcPr/>
+                </a:tc>
+              </a:tr>
+              <a:tr h="457200">
+                <a:tc>
+                  <a:txBody>
+                    <a:bodyPr/>
+                    <a:lstStyle/>
+                    <a:p>
+                      <a:r>
+                        <a:rPr sz="1500" b="0">
+                          <a:solidFill>
+                            <a:srgbClr val="1A1A1A"/>
+                          </a:solidFill>
+                        </a:rPr>
+                        <a:t>2. Sai e volta</a:t>
+                      </a:r>
+                    </a:p>
+                  </a:txBody>
+                  <a:tcPr/>
+                </a:tc>
+                <a:tc>
+                  <a:txBody>
+                    <a:bodyPr/>
+                    <a:lstStyle/>
+                    <a:p>
+                      <a:r>
+                        <a:rPr sz="1500" b="0">
+                          <a:solidFill>
+                            <a:srgbClr val="1A1A1A"/>
+                          </a:solidFill>
+                        </a:rPr>
+                        <a:t>Ele lembra do aparelho pelo MAC</a:t>
+                      </a:r>
+                    </a:p>
+                  </a:txBody>
+                  <a:tcPr/>
+                </a:tc>
+              </a:tr>
+              <a:tr h="457200">
+                <a:tc>
+                  <a:txBody>
+                    <a:bodyPr/>
+                    <a:lstStyle/>
+                    <a:p>
+                      <a:r>
+                        <a:rPr sz="1500" b="0">
+                          <a:solidFill>
+                            <a:srgbClr val="1A1A1A"/>
+                          </a:solidFill>
+                        </a:rPr>
+                        <a:t>3. Lotação</a:t>
+                      </a:r>
+                    </a:p>
+                  </a:txBody>
+                  <a:tcPr/>
+                </a:tc>
+                <a:tc>
+                  <a:txBody>
+                    <a:bodyPr/>
+                    <a:lstStyle/>
+                    <a:p>
+                      <a:r>
+                        <a:rPr sz="1500" b="0">
+                          <a:solidFill>
+                            <a:srgbClr val="1A1A1A"/>
+                          </a:solidFill>
+                        </a:rPr>
+                        <a:t>Acabaram os endereços: 169.254</a:t>
+                      </a:r>
+                    </a:p>
+                  </a:txBody>
+                  <a:tcPr/>
+                </a:tc>
+              </a:tr>
+              <a:tr h="457200">
+                <a:tc>
+                  <a:txBody>
+                    <a:bodyPr/>
+                    <a:lstStyle/>
+                    <a:p>
+                      <a:r>
+                        <a:rPr sz="1500" b="0">
+                          <a:solidFill>
+                            <a:srgbClr val="1A1A1A"/>
+                          </a:solidFill>
+                        </a:rPr>
+                        <a:t>4. MAC aleatório</a:t>
+                      </a:r>
+                    </a:p>
+                  </a:txBody>
+                  <a:tcPr/>
+                </a:tc>
+                <a:tc>
+                  <a:txBody>
+                    <a:bodyPr/>
+                    <a:lstStyle/>
+                    <a:p>
+                      <a:r>
+                        <a:rPr sz="1500" b="0">
+                          <a:solidFill>
+                            <a:srgbClr val="1A1A1A"/>
+                          </a:solidFill>
+                        </a:rPr>
+                        <a:t>Celular que troca de MAC ganha IP novo</a:t>
+                      </a:r>
+                    </a:p>
+                  </a:txBody>
+                  <a:tcPr/>
+                </a:tc>
+              </a:tr>
+              <a:tr h="457200">
+                <a:tc>
+                  <a:txBody>
+                    <a:bodyPr/>
+                    <a:lstStyle/>
+                    <a:p>
+                      <a:r>
+                        <a:rPr sz="1500" b="0">
+                          <a:solidFill>
+                            <a:srgbClr val="1A1A1A"/>
+                          </a:solidFill>
+                        </a:rPr>
+                        <a:t>5. Porteiro de folga</a:t>
+                      </a:r>
+                    </a:p>
+                  </a:txBody>
+                  <a:tcPr/>
+                </a:tc>
+                <a:tc>
+                  <a:txBody>
+                    <a:bodyPr/>
+                    <a:lstStyle/>
+                    <a:p>
+                      <a:r>
+                        <a:rPr sz="1500" b="0">
+                          <a:solidFill>
+                            <a:srgbClr val="1A1A1A"/>
+                          </a:solidFill>
+                        </a:rPr>
+                        <a:t>DHCP desligado: ninguém ganha endereço</a:t>
+                      </a:r>
+                    </a:p>
+                  </a:txBody>
+                  <a:tcPr/>
+                </a:tc>
+              </a:tr>
+              <a:tr h="457200">
+                <a:tc>
+                  <a:txBody>
+                    <a:bodyPr/>
+                    <a:lstStyle/>
+                    <a:p>
+                      <a:r>
+                        <a:rPr sz="1500" b="0">
+                          <a:solidFill>
+                            <a:srgbClr val="1A1A1A"/>
+                          </a:solidFill>
+                        </a:rPr>
+                        <a:t>6. A encomenda</a:t>
+                      </a:r>
+                    </a:p>
+                  </a:txBody>
+                  <a:tcPr/>
+                </a:tc>
+                <a:tc>
+                  <a:txBody>
+                    <a:bodyPr/>
+                    <a:lstStyle/>
+                    <a:p>
+                      <a:r>
+                        <a:rPr sz="1500" b="0">
+                          <a:solidFill>
+                            <a:srgbClr val="1A1A1A"/>
+                          </a:solidFill>
+                        </a:rPr>
+                        <a:t>O vídeo acha o celular certo pelo IP</a:t>
+                      </a:r>
+                    </a:p>
+                  </a:txBody>
+                  <a:tcPr/>
+                </a:tc>
+              </a:tr>
+              <a:tr h="457200">
+                <a:tc>
+                  <a:txBody>
+                    <a:bodyPr/>
+                    <a:lstStyle/>
+                    <a:p>
+                      <a:r>
+                        <a:rPr sz="1500" b="0">
+                          <a:solidFill>
+                            <a:srgbClr val="1A1A1A"/>
+                          </a:solidFill>
+                        </a:rPr>
+                        <a:t>7. O espertinho</a:t>
+                      </a:r>
+                    </a:p>
+                  </a:txBody>
+                  <a:tcPr/>
+                </a:tc>
+                <a:tc>
+                  <a:txBody>
+                    <a:bodyPr/>
+                    <a:lstStyle/>
+                    <a:p>
+                      <a:r>
+                        <a:rPr sz="1500" b="0">
+                          <a:solidFill>
+                            <a:srgbClr val="1A1A1A"/>
+                          </a:solidFill>
+                        </a:rPr>
+                        <a:t>IP fixo repetido: conflito de IP</a:t>
+                      </a:r>
+                    </a:p>
+                  </a:txBody>
+                  <a:tcPr/>
+                </a:tc>
+              </a:tr>
+            </a:tbl>
+          </a:graphicData>
+        </a:graphic>
+      </p:graphicFrame>
       <p:sp>
         <p:nvSpPr>
           <p:cNvPr id="7" name="TextBox 6"/>
-          <p:cNvSpPr txBox="1"/>
-          <p:nvPr/>
-        </p:nvSpPr>
-        <p:spPr>
-          <a:xfrm>
-            <a:off x="640080" y="5852160"/>
-            <a:ext cx="10881360" cy="457200"/>
-          </a:xfrm>
-          <a:prstGeom prst="rect">
-            <a:avLst/>
-          </a:prstGeom>
-          <a:noFill/>
-        </p:spPr>
-        <p:txBody>
-          <a:bodyPr wrap="square" lIns="0" rIns="0" tIns="0" bIns="0" anchor="t">
-            <a:spAutoFit/>
-          </a:bodyPr>
-          <a:lstStyle/>
-          <a:p>
-            <a:pPr algn="ctr"/>
-            <a:r>
-              <a:rPr sz="1600" b="0" i="1">
-                <a:solidFill>
-                  <a:srgbClr val="C5362B"/>
-                </a:solidFill>
-              </a:rPr>
-              <a:t>Fora a senha de administrador, hoje NÃO se muda nada. Só olhar.</a:t>
-            </a:r>
-          </a:p>
-        </p:txBody>
-      </p:sp>
-      <p:sp>
-        <p:nvSpPr>
-          <p:cNvPr id="8" name="TextBox 7"/>
           <p:cNvSpPr txBox="1"/>
           <p:nvPr/>
         </p:nvSpPr>
@@ -5209,7 +5565,7 @@
                   <a:srgbClr val="E88B1A"/>
                 </a:solidFill>
               </a:rPr>
-              <a:t>CUIDADO</a:t>
+              <a:t/>
             </a:r>
           </a:p>
         </p:txBody>
@@ -5240,10 +5596,10 @@
             <a:r>
               <a:rPr sz="3600" b="1" i="0">
                 <a:solidFill>
-                  <a:srgbClr val="0B5C5C"/>
-                </a:solidFill>
-              </a:rPr>
-              <a:t>O nome que aparece na lista</a:t>
+                  <a:srgbClr val="1A1A1A"/>
+                </a:solidFill>
+              </a:rPr>
+              <a:t>INTERVALO</a:t>
             </a:r>
           </a:p>
           <a:p>
@@ -5251,21 +5607,10 @@
             <a:r>
               <a:rPr sz="3600" b="1" i="0">
                 <a:solidFill>
-                  <a:srgbClr val="0B5C5C"/>
-                </a:solidFill>
-              </a:rPr>
-              <a:t>quem escolhe é o aparelho.</a:t>
-            </a:r>
-          </a:p>
-          <a:p>
-            <a:pPr algn="ctr"/>
-            <a:r>
-              <a:rPr sz="3600" b="1" i="0">
-                <a:solidFill>
-                  <a:srgbClr val="0B5C5C"/>
-                </a:solidFill>
-              </a:rPr>
-              <a:t>Quem identifica é o MAC.</a:t>
+                  <a:srgbClr val="1A1A1A"/>
+                </a:solidFill>
+              </a:rPr>
+              <a:t>15 minutos</a:t>
             </a:r>
           </a:p>
         </p:txBody>
@@ -5373,8 +5718,8 @@
         </p:nvSpPr>
         <p:spPr>
           <a:xfrm>
-            <a:off x="640080" y="365760"/>
-            <a:ext cx="10881360" cy="320040"/>
+            <a:off x="640080" y="1463040"/>
+            <a:ext cx="10881360" cy="457200"/>
           </a:xfrm>
           <a:prstGeom prst="rect">
             <a:avLst/>
@@ -5387,14 +5732,14 @@
           </a:bodyPr>
           <a:lstStyle/>
           <a:p>
-            <a:pPr algn="l"/>
-            <a:r>
-              <a:rPr sz="1300" b="1" i="0">
+            <a:pPr algn="ctr"/>
+            <a:r>
+              <a:rPr sz="1600" b="1" i="0">
                 <a:solidFill>
                   <a:srgbClr val="E88B1A"/>
                 </a:solidFill>
               </a:rPr>
-              <a:t>PRÁTICA · 15 MIN</a:t>
+              <a:t>DEPOIS DO INTERVALO</a:t>
             </a:r>
           </a:p>
         </p:txBody>
@@ -5407,8 +5752,8 @@
         </p:nvSpPr>
         <p:spPr>
           <a:xfrm>
-            <a:off x="640080" y="685800"/>
-            <a:ext cx="10881360" cy="822960"/>
+            <a:off x="822960" y="2194560"/>
+            <a:ext cx="10515600" cy="2743200"/>
           </a:xfrm>
           <a:prstGeom prst="rect">
             <a:avLst/>
@@ -5421,176 +5766,43 @@
           </a:bodyPr>
           <a:lstStyle/>
           <a:p>
-            <a:pPr algn="l"/>
-            <a:r>
-              <a:rPr sz="3400" b="1" i="0">
+            <a:pPr algn="ctr"/>
+            <a:r>
+              <a:rPr sz="3600" b="1" i="0">
                 <a:solidFill>
                   <a:srgbClr val="0B5C5C"/>
                 </a:solidFill>
               </a:rPr>
-              <a:t>Caça ao intruso</a:t>
-            </a:r>
-          </a:p>
-        </p:txBody>
-      </p:sp>
-      <p:sp>
-        <p:nvSpPr>
-          <p:cNvPr id="5" name="Rectangle 4"/>
-          <p:cNvSpPr/>
-          <p:nvPr/>
-        </p:nvSpPr>
-        <p:spPr>
-          <a:xfrm>
-            <a:off x="640080" y="1554480"/>
-            <a:ext cx="10881360" cy="54864"/>
-          </a:xfrm>
-          <a:prstGeom prst="rect">
-            <a:avLst/>
-          </a:prstGeom>
-          <a:solidFill>
-            <a:srgbClr val="0B5C5C"/>
-          </a:solidFill>
-          <a:ln>
-            <a:noFill/>
-          </a:ln>
-        </p:spPr>
-        <p:style>
-          <a:lnRef idx="1">
-            <a:schemeClr val="accent1"/>
-          </a:lnRef>
-          <a:fillRef idx="3">
-            <a:schemeClr val="accent1"/>
-          </a:fillRef>
-          <a:effectRef idx="2">
-            <a:schemeClr val="accent1"/>
-          </a:effectRef>
-          <a:fontRef idx="minor">
-            <a:schemeClr val="lt1"/>
-          </a:fontRef>
-        </p:style>
-        <p:txBody>
-          <a:bodyPr rtlCol="0" anchor="ctr"/>
-          <a:lstStyle/>
+              <a:t>O Livro da portaria</a:t>
+            </a:r>
+          </a:p>
           <a:p>
             <a:pPr algn="ctr"/>
-          </a:p>
-        </p:txBody>
-      </p:sp>
-      <p:sp>
-        <p:nvSpPr>
-          <p:cNvPr id="6" name="TextBox 5"/>
-          <p:cNvSpPr txBox="1"/>
-          <p:nvPr/>
-        </p:nvSpPr>
-        <p:spPr>
-          <a:xfrm>
-            <a:off x="640080" y="2560320"/>
-            <a:ext cx="10881360" cy="3474720"/>
-          </a:xfrm>
-          <a:prstGeom prst="rect">
-            <a:avLst/>
-          </a:prstGeom>
-          <a:noFill/>
-        </p:spPr>
-        <p:txBody>
-          <a:bodyPr wrap="square" lIns="0" rIns="0" tIns="0" bIns="0" anchor="t">
-            <a:spAutoFit/>
-          </a:bodyPr>
-          <a:lstStyle/>
-          <a:p>
-            <a:pPr algn="l"/>
-            <a:r>
-              <a:rPr sz="2200" b="0" i="0">
-                <a:solidFill>
-                  <a:srgbClr val="1A1A1A"/>
-                </a:solidFill>
-              </a:rPr>
-              <a:t>Uma das redes foi invadida.</a:t>
-            </a:r>
-          </a:p>
-          <a:p>
-            <a:pPr algn="l"/>
-            <a:r>
-              <a:rPr sz="2200" b="0" i="0">
-                <a:solidFill>
-                  <a:srgbClr val="1A1A1A"/>
-                </a:solidFill>
-              </a:rPr>
-              <a:t/>
-            </a:r>
-          </a:p>
-          <a:p>
-            <a:pPr algn="l"/>
-            <a:r>
-              <a:rPr sz="2200" b="0" i="0">
-                <a:solidFill>
-                  <a:srgbClr val="1A1A1A"/>
-                </a:solidFill>
-              </a:rPr>
-              <a:t>•  Confira a lista da sua equipe</a:t>
-            </a:r>
-          </a:p>
-          <a:p>
-            <a:pPr algn="l"/>
-            <a:r>
-              <a:rPr sz="2200" b="0" i="0">
-                <a:solidFill>
-                  <a:srgbClr val="1A1A1A"/>
-                </a:solidFill>
-              </a:rPr>
-              <a:t>•  Qual aparelho é o intruso? IP? MAC?</a:t>
-            </a:r>
-          </a:p>
-          <a:p>
-            <a:pPr algn="l"/>
-            <a:r>
-              <a:rPr sz="2200" b="0" i="0">
-                <a:solidFill>
-                  <a:srgbClr val="1A1A1A"/>
-                </a:solidFill>
-              </a:rPr>
-              <a:t>•  Como vocês chegaram nessa conclusão?</a:t>
-            </a:r>
-          </a:p>
-        </p:txBody>
-      </p:sp>
-      <p:sp>
-        <p:nvSpPr>
-          <p:cNvPr id="7" name="TextBox 6"/>
-          <p:cNvSpPr txBox="1"/>
-          <p:nvPr/>
-        </p:nvSpPr>
-        <p:spPr>
-          <a:xfrm>
-            <a:off x="640080" y="5852160"/>
-            <a:ext cx="10881360" cy="457200"/>
-          </a:xfrm>
-          <a:prstGeom prst="rect">
-            <a:avLst/>
-          </a:prstGeom>
-          <a:noFill/>
-        </p:spPr>
-        <p:txBody>
-          <a:bodyPr wrap="square" lIns="0" rIns="0" tIns="0" bIns="0" anchor="t">
-            <a:spAutoFit/>
-          </a:bodyPr>
-          <a:lstStyle/>
+            <a:r>
+              <a:rPr sz="3600" b="1" i="0">
+                <a:solidFill>
+                  <a:srgbClr val="0B5C5C"/>
+                </a:solidFill>
+              </a:rPr>
+              <a:t>existe de verdade.</a:t>
+            </a:r>
+          </a:p>
           <a:p>
             <a:pPr algn="ctr"/>
             <a:r>
-              <a:rPr sz="1600" b="0" i="1">
-                <a:solidFill>
-                  <a:srgbClr val="E88B1A"/>
-                </a:solidFill>
-              </a:rPr>
-              <a:t>No cliente: "acho que o vizinho tá usando meu Wi-Fi".</a:t>
-            </a:r>
-          </a:p>
-        </p:txBody>
-      </p:sp>
-      <p:sp>
-        <p:nvSpPr>
-          <p:cNvPr id="8" name="TextBox 7"/>
+              <a:rPr sz="3600" b="1" i="0">
+                <a:solidFill>
+                  <a:srgbClr val="0B5C5C"/>
+                </a:solidFill>
+              </a:rPr>
+              <a:t>Vamos abrir o do roteador.</a:t>
+            </a:r>
+          </a:p>
+        </p:txBody>
+      </p:sp>
+      <p:sp>
+        <p:nvSpPr>
+          <p:cNvPr id="5" name="TextBox 4"/>
           <p:cNvSpPr txBox="1"/>
           <p:nvPr/>
         </p:nvSpPr>
@@ -5712,7 +5924,7 @@
                   <a:srgbClr val="E88B1A"/>
                 </a:solidFill>
               </a:rPr>
-              <a:t>ESTAÇÃO A</a:t>
+              <a:t>PRÁTICA · 35 MIN</a:t>
             </a:r>
           </a:p>
         </p:txBody>
@@ -5746,7 +5958,7 @@
                   <a:srgbClr val="0B5C5C"/>
                 </a:solidFill>
               </a:rPr>
-              <a:t>Ping: bater na porta</a:t>
+              <a:t>Quem está na rede?</a:t>
             </a:r>
           </a:p>
         </p:txBody>
@@ -5818,67 +6030,56 @@
           <a:p>
             <a:pPr algn="l"/>
             <a:r>
-              <a:rPr sz="1900" b="0" i="0">
+              <a:rPr sz="2000" b="0" i="0">
                 <a:solidFill>
                   <a:srgbClr val="1A1A1A"/>
                 </a:solidFill>
               </a:rPr>
-              <a:t>ping 192.168.0.1                  → a portaria responde?</a:t>
-            </a:r>
-          </a:p>
-          <a:p>
-            <a:pPr algn="l"/>
-            <a:r>
-              <a:rPr sz="1900" b="0" i="0">
+              <a:t>1.  No navegador do celular: 192.168.0.1</a:t>
+            </a:r>
+          </a:p>
+          <a:p>
+            <a:pPr algn="l"/>
+            <a:r>
+              <a:rPr sz="2000" b="0" i="0">
                 <a:solidFill>
                   <a:srgbClr val="1A1A1A"/>
                 </a:solidFill>
               </a:rPr>
-              <a:t>ping (IP do celular do colega)  → ele responde?</a:t>
-            </a:r>
-          </a:p>
-          <a:p>
-            <a:pPr algn="l"/>
-            <a:r>
-              <a:rPr sz="1900" b="0" i="0">
+              <a:t>2.  Primeiro acesso: crie a senha de administrador que o professor ditar</a:t>
+            </a:r>
+          </a:p>
+          <a:p>
+            <a:pPr algn="l"/>
+            <a:r>
+              <a:rPr sz="2000" b="0" i="0">
                 <a:solidFill>
                   <a:srgbClr val="1A1A1A"/>
                 </a:solidFill>
               </a:rPr>
-              <a:t>Colega desliga o Wi-Fi e pinga de novo</a:t>
-            </a:r>
-          </a:p>
-          <a:p>
-            <a:pPr algn="l"/>
-            <a:r>
-              <a:rPr sz="1900" b="0" i="0">
+              <a:t>3.  Assistente de configuração? Pule. Ache a lista de aparelhos</a:t>
+            </a:r>
+          </a:p>
+          <a:p>
+            <a:pPr algn="l"/>
+            <a:r>
+              <a:rPr sz="2000" b="0" i="0">
                 <a:solidFill>
                   <a:srgbClr val="1A1A1A"/>
                 </a:solidFill>
               </a:rPr>
-              <a:t/>
-            </a:r>
-          </a:p>
-          <a:p>
-            <a:pPr algn="l"/>
-            <a:r>
-              <a:rPr sz="1900" b="0" i="0">
+              <a:t>4.  Anote nome, IP e MAC de cada um — e de quem é</a:t>
+            </a:r>
+          </a:p>
+          <a:p>
+            <a:pPr algn="l"/>
+            <a:r>
+              <a:rPr sz="2000" b="0" i="0">
                 <a:solidFill>
                   <a:srgbClr val="1A1A1A"/>
                 </a:solidFill>
               </a:rPr>
-              <a:t>Respondeu: está lá e o caminho funciona.</a:t>
-            </a:r>
-          </a:p>
-          <a:p>
-            <a:pPr algn="l"/>
-            <a:r>
-              <a:rPr sz="1900" b="0" i="0">
-                <a:solidFill>
-                  <a:srgbClr val="1A1A1A"/>
-                </a:solidFill>
-              </a:rPr>
-              <a:t>Não respondeu: não está, caminho quebrado — ou ele não abre a porta.</a:t>
+              <a:t>5.  O MAC bate com o que você anotou?</a:t>
             </a:r>
           </a:p>
         </p:txBody>
@@ -5886,6 +6087,40 @@
       <p:sp>
         <p:nvSpPr>
           <p:cNvPr id="7" name="TextBox 6"/>
+          <p:cNvSpPr txBox="1"/>
+          <p:nvPr/>
+        </p:nvSpPr>
+        <p:spPr>
+          <a:xfrm>
+            <a:off x="640080" y="5852160"/>
+            <a:ext cx="10881360" cy="457200"/>
+          </a:xfrm>
+          <a:prstGeom prst="rect">
+            <a:avLst/>
+          </a:prstGeom>
+          <a:noFill/>
+        </p:spPr>
+        <p:txBody>
+          <a:bodyPr wrap="square" lIns="0" rIns="0" tIns="0" bIns="0" anchor="t">
+            <a:spAutoFit/>
+          </a:bodyPr>
+          <a:lstStyle/>
+          <a:p>
+            <a:pPr algn="ctr"/>
+            <a:r>
+              <a:rPr sz="1600" b="0" i="1">
+                <a:solidFill>
+                  <a:srgbClr val="C5362B"/>
+                </a:solidFill>
+              </a:rPr>
+              <a:t>Fora a senha de administrador, hoje NÃO se muda nada. Só olhar.</a:t>
+            </a:r>
+          </a:p>
+        </p:txBody>
+      </p:sp>
+      <p:sp>
+        <p:nvSpPr>
+          <p:cNvPr id="8" name="TextBox 7"/>
           <p:cNvSpPr txBox="1"/>
           <p:nvPr/>
         </p:nvSpPr>
@@ -6259,8 +6494,8 @@
         </p:nvSpPr>
         <p:spPr>
           <a:xfrm>
-            <a:off x="640080" y="365760"/>
-            <a:ext cx="10881360" cy="320040"/>
+            <a:off x="640080" y="1463040"/>
+            <a:ext cx="10881360" cy="457200"/>
           </a:xfrm>
           <a:prstGeom prst="rect">
             <a:avLst/>
@@ -6273,14 +6508,14 @@
           </a:bodyPr>
           <a:lstStyle/>
           <a:p>
-            <a:pPr algn="l"/>
-            <a:r>
-              <a:rPr sz="1300" b="1" i="0">
+            <a:pPr algn="ctr"/>
+            <a:r>
+              <a:rPr sz="1600" b="1" i="0">
                 <a:solidFill>
                   <a:srgbClr val="E88B1A"/>
                 </a:solidFill>
               </a:rPr>
-              <a:t>ESTAÇÃO B</a:t>
+              <a:t>CUIDADO</a:t>
             </a:r>
           </a:p>
         </p:txBody>
@@ -6293,8 +6528,8 @@
         </p:nvSpPr>
         <p:spPr>
           <a:xfrm>
-            <a:off x="640080" y="685800"/>
-            <a:ext cx="10881360" cy="822960"/>
+            <a:off x="822960" y="2194560"/>
+            <a:ext cx="10515600" cy="2743200"/>
           </a:xfrm>
           <a:prstGeom prst="rect">
             <a:avLst/>
@@ -6307,131 +6542,43 @@
           </a:bodyPr>
           <a:lstStyle/>
           <a:p>
-            <a:pPr algn="l"/>
-            <a:r>
-              <a:rPr sz="3400" b="1" i="0">
+            <a:pPr algn="ctr"/>
+            <a:r>
+              <a:rPr sz="3600" b="1" i="0">
                 <a:solidFill>
                   <a:srgbClr val="0B5C5C"/>
                 </a:solidFill>
               </a:rPr>
-              <a:t>O roteador mudo</a:t>
-            </a:r>
-          </a:p>
-        </p:txBody>
-      </p:sp>
-      <p:sp>
-        <p:nvSpPr>
-          <p:cNvPr id="5" name="Rectangle 4"/>
-          <p:cNvSpPr/>
-          <p:nvPr/>
-        </p:nvSpPr>
-        <p:spPr>
-          <a:xfrm>
-            <a:off x="640080" y="1554480"/>
-            <a:ext cx="10881360" cy="54864"/>
-          </a:xfrm>
-          <a:prstGeom prst="rect">
-            <a:avLst/>
-          </a:prstGeom>
-          <a:solidFill>
-            <a:srgbClr val="0B5C5C"/>
-          </a:solidFill>
-          <a:ln>
-            <a:noFill/>
-          </a:ln>
-        </p:spPr>
-        <p:style>
-          <a:lnRef idx="1">
-            <a:schemeClr val="accent1"/>
-          </a:lnRef>
-          <a:fillRef idx="3">
-            <a:schemeClr val="accent1"/>
-          </a:fillRef>
-          <a:effectRef idx="2">
-            <a:schemeClr val="accent1"/>
-          </a:effectRef>
-          <a:fontRef idx="minor">
-            <a:schemeClr val="lt1"/>
-          </a:fontRef>
-        </p:style>
-        <p:txBody>
-          <a:bodyPr rtlCol="0" anchor="ctr"/>
-          <a:lstStyle/>
+              <a:t>O nome que aparece na lista</a:t>
+            </a:r>
+          </a:p>
           <a:p>
             <a:pPr algn="ctr"/>
-          </a:p>
-        </p:txBody>
-      </p:sp>
-      <p:sp>
-        <p:nvSpPr>
-          <p:cNvPr id="6" name="TextBox 5"/>
-          <p:cNvSpPr txBox="1"/>
-          <p:nvPr/>
-        </p:nvSpPr>
-        <p:spPr>
-          <a:xfrm>
-            <a:off x="640080" y="2560320"/>
-            <a:ext cx="10881360" cy="3474720"/>
-          </a:xfrm>
-          <a:prstGeom prst="rect">
-            <a:avLst/>
-          </a:prstGeom>
-          <a:noFill/>
-        </p:spPr>
-        <p:txBody>
-          <a:bodyPr wrap="square" lIns="0" rIns="0" tIns="0" bIns="0" anchor="t">
-            <a:spAutoFit/>
-          </a:bodyPr>
-          <a:lstStyle/>
-          <a:p>
-            <a:pPr algn="l"/>
-            <a:r>
-              <a:rPr sz="2200" b="0" i="0">
-                <a:solidFill>
-                  <a:srgbClr val="1A1A1A"/>
-                </a:solidFill>
-              </a:rPr>
-              <a:t>•  Liga o computador por cabo. A luz acende</a:t>
-            </a:r>
-          </a:p>
-          <a:p>
-            <a:pPr algn="l"/>
-            <a:r>
-              <a:rPr sz="2200" b="0" i="0">
-                <a:solidFill>
-                  <a:srgbClr val="1A1A1A"/>
-                </a:solidFill>
-              </a:rPr>
-              <a:t>•  ipconfig — o que aparece?</a:t>
-            </a:r>
-          </a:p>
-          <a:p>
-            <a:pPr algn="l"/>
-            <a:r>
-              <a:rPr sz="2200" b="0" i="0">
-                <a:solidFill>
-                  <a:srgbClr val="1A1A1A"/>
-                </a:solidFill>
-              </a:rPr>
-              <a:t>•  Tenta o celular no Wi-Fi dele — o que acontece?</a:t>
-            </a:r>
-          </a:p>
-          <a:p>
-            <a:pPr algn="l"/>
-            <a:r>
-              <a:rPr sz="2200" b="0" i="0">
-                <a:solidFill>
-                  <a:srgbClr val="1A1A1A"/>
-                </a:solidFill>
-              </a:rPr>
-              <a:t>•  Escreva o diagnóstico</a:t>
-            </a:r>
-          </a:p>
-        </p:txBody>
-      </p:sp>
-      <p:sp>
-        <p:nvSpPr>
-          <p:cNvPr id="7" name="TextBox 6"/>
+            <a:r>
+              <a:rPr sz="3600" b="1" i="0">
+                <a:solidFill>
+                  <a:srgbClr val="0B5C5C"/>
+                </a:solidFill>
+              </a:rPr>
+              <a:t>quem escolhe é o aparelho.</a:t>
+            </a:r>
+          </a:p>
+          <a:p>
+            <a:pPr algn="ctr"/>
+            <a:r>
+              <a:rPr sz="3600" b="1" i="0">
+                <a:solidFill>
+                  <a:srgbClr val="0B5C5C"/>
+                </a:solidFill>
+              </a:rPr>
+              <a:t>Quem identifica é o MAC.</a:t>
+            </a:r>
+          </a:p>
+        </p:txBody>
+      </p:sp>
+      <p:sp>
+        <p:nvSpPr>
+          <p:cNvPr id="5" name="TextBox 4"/>
           <p:cNvSpPr txBox="1"/>
           <p:nvPr/>
         </p:nvSpPr>
@@ -6553,7 +6700,7 @@
                   <a:srgbClr val="E88B1A"/>
                 </a:solidFill>
               </a:rPr>
-              <a:t>LEIA A TELA</a:t>
+              <a:t>PRÁTICA · 15 MIN</a:t>
             </a:r>
           </a:p>
         </p:txBody>
@@ -6587,7 +6734,7 @@
                   <a:srgbClr val="0B5C5C"/>
                 </a:solidFill>
               </a:rPr>
-              <a:t>Tela A: o que está acontecendo?</a:t>
+              <a:t>Caça ao intruso</a:t>
             </a:r>
           </a:p>
         </p:txBody>
@@ -6637,57 +6784,14 @@
       </p:sp>
       <p:sp>
         <p:nvSpPr>
-          <p:cNvPr id="6" name="Rectangle 5"/>
-          <p:cNvSpPr/>
-          <p:nvPr/>
-        </p:nvSpPr>
-        <p:spPr>
-          <a:xfrm>
-            <a:off x="640080" y="2286000"/>
-            <a:ext cx="10881360" cy="3108960"/>
-          </a:xfrm>
-          <a:prstGeom prst="rect">
-            <a:avLst/>
-          </a:prstGeom>
-          <a:solidFill>
-            <a:srgbClr val="1A1A1A"/>
-          </a:solidFill>
-          <a:ln>
-            <a:noFill/>
-          </a:ln>
-        </p:spPr>
-        <p:style>
-          <a:lnRef idx="1">
-            <a:schemeClr val="accent1"/>
-          </a:lnRef>
-          <a:fillRef idx="3">
-            <a:schemeClr val="accent1"/>
-          </a:fillRef>
-          <a:effectRef idx="2">
-            <a:schemeClr val="accent1"/>
-          </a:effectRef>
-          <a:fontRef idx="minor">
-            <a:schemeClr val="lt1"/>
-          </a:fontRef>
-        </p:style>
-        <p:txBody>
-          <a:bodyPr rtlCol="0" anchor="ctr"/>
-          <a:lstStyle/>
-          <a:p>
-            <a:pPr algn="ctr"/>
-          </a:p>
-        </p:txBody>
-      </p:sp>
-      <p:sp>
-        <p:nvSpPr>
-          <p:cNvPr id="7" name="TextBox 6"/>
+          <p:cNvPr id="6" name="TextBox 5"/>
           <p:cNvSpPr txBox="1"/>
           <p:nvPr/>
         </p:nvSpPr>
         <p:spPr>
           <a:xfrm>
-            <a:off x="914400" y="2514600"/>
-            <a:ext cx="10332720" cy="2743200"/>
+            <a:off x="640080" y="2560320"/>
+            <a:ext cx="10881360" cy="3474720"/>
           </a:xfrm>
           <a:prstGeom prst="rect">
             <a:avLst/>
@@ -6702,49 +6806,90 @@
           <a:p>
             <a:pPr algn="l"/>
             <a:r>
-              <a:rPr sz="2000" b="0" i="0">
-                <a:solidFill>
-                  <a:srgbClr val="FFFFFF"/>
-                </a:solidFill>
-                <a:latin typeface="Consolas"/>
-              </a:rPr>
-              <a:t>Adaptador Ethernet Ethernet:</a:t>
-            </a:r>
-          </a:p>
-          <a:p>
-            <a:pPr algn="l"/>
-            <a:r>
-              <a:rPr sz="2000" b="0" i="0">
-                <a:solidFill>
-                  <a:srgbClr val="FFFFFF"/>
-                </a:solidFill>
-                <a:latin typeface="Consolas"/>
-              </a:rPr>
-              <a:t>   Endereço IPv4. . . . . . . . . . . : 192.168.0.104</a:t>
-            </a:r>
-          </a:p>
-          <a:p>
-            <a:pPr algn="l"/>
-            <a:r>
-              <a:rPr sz="2000" b="0" i="0">
-                <a:solidFill>
-                  <a:srgbClr val="FFFFFF"/>
-                </a:solidFill>
-                <a:latin typeface="Consolas"/>
-              </a:rPr>
-              <a:t>   Máscara de Sub-rede . . . . . . . . : 255.255.255.0</a:t>
-            </a:r>
-          </a:p>
-          <a:p>
-            <a:pPr algn="l"/>
-            <a:r>
-              <a:rPr sz="2000" b="0" i="0">
-                <a:solidFill>
-                  <a:srgbClr val="FFFFFF"/>
-                </a:solidFill>
-                <a:latin typeface="Consolas"/>
-              </a:rPr>
-              <a:t>   Gateway Padrão. . . . . . . . . . . : 192.168.0.1</a:t>
+              <a:rPr sz="2200" b="0" i="0">
+                <a:solidFill>
+                  <a:srgbClr val="1A1A1A"/>
+                </a:solidFill>
+              </a:rPr>
+              <a:t>Uma das redes foi invadida.</a:t>
+            </a:r>
+          </a:p>
+          <a:p>
+            <a:pPr algn="l"/>
+            <a:r>
+              <a:rPr sz="2200" b="0" i="0">
+                <a:solidFill>
+                  <a:srgbClr val="1A1A1A"/>
+                </a:solidFill>
+              </a:rPr>
+              <a:t/>
+            </a:r>
+          </a:p>
+          <a:p>
+            <a:pPr algn="l"/>
+            <a:r>
+              <a:rPr sz="2200" b="0" i="0">
+                <a:solidFill>
+                  <a:srgbClr val="1A1A1A"/>
+                </a:solidFill>
+              </a:rPr>
+              <a:t>•  Confira a lista da sua equipe</a:t>
+            </a:r>
+          </a:p>
+          <a:p>
+            <a:pPr algn="l"/>
+            <a:r>
+              <a:rPr sz="2200" b="0" i="0">
+                <a:solidFill>
+                  <a:srgbClr val="1A1A1A"/>
+                </a:solidFill>
+              </a:rPr>
+              <a:t>•  Qual aparelho é o intruso? IP? MAC?</a:t>
+            </a:r>
+          </a:p>
+          <a:p>
+            <a:pPr algn="l"/>
+            <a:r>
+              <a:rPr sz="2200" b="0" i="0">
+                <a:solidFill>
+                  <a:srgbClr val="1A1A1A"/>
+                </a:solidFill>
+              </a:rPr>
+              <a:t>•  Como vocês chegaram nessa conclusão?</a:t>
+            </a:r>
+          </a:p>
+        </p:txBody>
+      </p:sp>
+      <p:sp>
+        <p:nvSpPr>
+          <p:cNvPr id="7" name="TextBox 6"/>
+          <p:cNvSpPr txBox="1"/>
+          <p:nvPr/>
+        </p:nvSpPr>
+        <p:spPr>
+          <a:xfrm>
+            <a:off x="640080" y="5852160"/>
+            <a:ext cx="10881360" cy="457200"/>
+          </a:xfrm>
+          <a:prstGeom prst="rect">
+            <a:avLst/>
+          </a:prstGeom>
+          <a:noFill/>
+        </p:spPr>
+        <p:txBody>
+          <a:bodyPr wrap="square" lIns="0" rIns="0" tIns="0" bIns="0" anchor="t">
+            <a:spAutoFit/>
+          </a:bodyPr>
+          <a:lstStyle/>
+          <a:p>
+            <a:pPr algn="ctr"/>
+            <a:r>
+              <a:rPr sz="1600" b="0" i="1">
+                <a:solidFill>
+                  <a:srgbClr val="E88B1A"/>
+                </a:solidFill>
+              </a:rPr>
+              <a:t>No cliente: "acho que o vizinho tá usando meu Wi-Fi".</a:t>
             </a:r>
           </a:p>
         </p:txBody>
@@ -6873,7 +7018,7 @@
                   <a:srgbClr val="E88B1A"/>
                 </a:solidFill>
               </a:rPr>
-              <a:t>LEIA A TELA</a:t>
+              <a:t>ESTAÇÃO A</a:t>
             </a:r>
           </a:p>
         </p:txBody>
@@ -6907,7 +7052,7 @@
                   <a:srgbClr val="0B5C5C"/>
                 </a:solidFill>
               </a:rPr>
-              <a:t>Tela B: o que está acontecendo?</a:t>
+              <a:t>Ping: bater na porta</a:t>
             </a:r>
           </a:p>
         </p:txBody>
@@ -6957,57 +7102,14 @@
       </p:sp>
       <p:sp>
         <p:nvSpPr>
-          <p:cNvPr id="6" name="Rectangle 5"/>
-          <p:cNvSpPr/>
-          <p:nvPr/>
-        </p:nvSpPr>
-        <p:spPr>
-          <a:xfrm>
-            <a:off x="640080" y="2286000"/>
-            <a:ext cx="10881360" cy="3108960"/>
-          </a:xfrm>
-          <a:prstGeom prst="rect">
-            <a:avLst/>
-          </a:prstGeom>
-          <a:solidFill>
-            <a:srgbClr val="1A1A1A"/>
-          </a:solidFill>
-          <a:ln>
-            <a:noFill/>
-          </a:ln>
-        </p:spPr>
-        <p:style>
-          <a:lnRef idx="1">
-            <a:schemeClr val="accent1"/>
-          </a:lnRef>
-          <a:fillRef idx="3">
-            <a:schemeClr val="accent1"/>
-          </a:fillRef>
-          <a:effectRef idx="2">
-            <a:schemeClr val="accent1"/>
-          </a:effectRef>
-          <a:fontRef idx="minor">
-            <a:schemeClr val="lt1"/>
-          </a:fontRef>
-        </p:style>
-        <p:txBody>
-          <a:bodyPr rtlCol="0" anchor="ctr"/>
-          <a:lstStyle/>
-          <a:p>
-            <a:pPr algn="ctr"/>
-          </a:p>
-        </p:txBody>
-      </p:sp>
-      <p:sp>
-        <p:nvSpPr>
-          <p:cNvPr id="7" name="TextBox 6"/>
+          <p:cNvPr id="6" name="TextBox 5"/>
           <p:cNvSpPr txBox="1"/>
           <p:nvPr/>
         </p:nvSpPr>
         <p:spPr>
           <a:xfrm>
-            <a:off x="914400" y="2514600"/>
-            <a:ext cx="10332720" cy="2743200"/>
+            <a:off x="640080" y="2560320"/>
+            <a:ext cx="10881360" cy="3474720"/>
           </a:xfrm>
           <a:prstGeom prst="rect">
             <a:avLst/>
@@ -7022,56 +7124,74 @@
           <a:p>
             <a:pPr algn="l"/>
             <a:r>
-              <a:rPr sz="2000" b="0" i="0">
-                <a:solidFill>
-                  <a:srgbClr val="FFFFFF"/>
-                </a:solidFill>
-                <a:latin typeface="Consolas"/>
-              </a:rPr>
-              <a:t>Adaptador Ethernet Ethernet:</a:t>
-            </a:r>
-          </a:p>
-          <a:p>
-            <a:pPr algn="l"/>
-            <a:r>
-              <a:rPr sz="2000" b="0" i="0">
-                <a:solidFill>
-                  <a:srgbClr val="FFFFFF"/>
-                </a:solidFill>
-                <a:latin typeface="Consolas"/>
-              </a:rPr>
-              <a:t>   Endereço IPv4 de Configuração Automática: 169.254.37.112</a:t>
-            </a:r>
-          </a:p>
-          <a:p>
-            <a:pPr algn="l"/>
-            <a:r>
-              <a:rPr sz="2000" b="0" i="0">
-                <a:solidFill>
-                  <a:srgbClr val="FFFFFF"/>
-                </a:solidFill>
-                <a:latin typeface="Consolas"/>
-              </a:rPr>
-              <a:t>   Máscara de Sub-rede . . . . . . . . : 255.255.0.0</a:t>
-            </a:r>
-          </a:p>
-          <a:p>
-            <a:pPr algn="l"/>
-            <a:r>
-              <a:rPr sz="2000" b="0" i="0">
-                <a:solidFill>
-                  <a:srgbClr val="FFFFFF"/>
-                </a:solidFill>
-                <a:latin typeface="Consolas"/>
-              </a:rPr>
-              <a:t>   Gateway Padrão. . . . . . . . . . . :</a:t>
-            </a:r>
-          </a:p>
-        </p:txBody>
-      </p:sp>
-      <p:sp>
-        <p:nvSpPr>
-          <p:cNvPr id="8" name="TextBox 7"/>
+              <a:rPr sz="1900" b="0" i="0">
+                <a:solidFill>
+                  <a:srgbClr val="1A1A1A"/>
+                </a:solidFill>
+              </a:rPr>
+              <a:t>ping 192.168.0.1                  → a portaria responde?</a:t>
+            </a:r>
+          </a:p>
+          <a:p>
+            <a:pPr algn="l"/>
+            <a:r>
+              <a:rPr sz="1900" b="0" i="0">
+                <a:solidFill>
+                  <a:srgbClr val="1A1A1A"/>
+                </a:solidFill>
+              </a:rPr>
+              <a:t>ping (IP do celular do colega)  → ele responde?</a:t>
+            </a:r>
+          </a:p>
+          <a:p>
+            <a:pPr algn="l"/>
+            <a:r>
+              <a:rPr sz="1900" b="0" i="0">
+                <a:solidFill>
+                  <a:srgbClr val="1A1A1A"/>
+                </a:solidFill>
+              </a:rPr>
+              <a:t>Colega desliga o Wi-Fi e pinga de novo</a:t>
+            </a:r>
+          </a:p>
+          <a:p>
+            <a:pPr algn="l"/>
+            <a:r>
+              <a:rPr sz="1900" b="0" i="0">
+                <a:solidFill>
+                  <a:srgbClr val="1A1A1A"/>
+                </a:solidFill>
+              </a:rPr>
+              <a:t/>
+            </a:r>
+          </a:p>
+          <a:p>
+            <a:pPr algn="l"/>
+            <a:r>
+              <a:rPr sz="1900" b="0" i="0">
+                <a:solidFill>
+                  <a:srgbClr val="1A1A1A"/>
+                </a:solidFill>
+              </a:rPr>
+              <a:t>Respondeu: está lá e o caminho funciona.</a:t>
+            </a:r>
+          </a:p>
+          <a:p>
+            <a:pPr algn="l"/>
+            <a:r>
+              <a:rPr sz="1900" b="0" i="0">
+                <a:solidFill>
+                  <a:srgbClr val="1A1A1A"/>
+                </a:solidFill>
+              </a:rPr>
+              <a:t>Não respondeu: não está, caminho quebrado — ou ele não abre a porta.</a:t>
+            </a:r>
+          </a:p>
+        </p:txBody>
+      </p:sp>
+      <p:sp>
+        <p:nvSpPr>
+          <p:cNvPr id="7" name="TextBox 6"/>
           <p:cNvSpPr txBox="1"/>
           <p:nvPr/>
         </p:nvSpPr>
@@ -7193,7 +7313,7 @@
                   <a:srgbClr val="E88B1A"/>
                 </a:solidFill>
               </a:rPr>
-              <a:t>LEIA A TELA</a:t>
+              <a:t>ESTAÇÃO B</a:t>
             </a:r>
           </a:p>
         </p:txBody>
@@ -7227,7 +7347,7 @@
                   <a:srgbClr val="0B5C5C"/>
                 </a:solidFill>
               </a:rPr>
-              <a:t>Tela C: o que está acontecendo?</a:t>
+              <a:t>O roteador mudo</a:t>
             </a:r>
           </a:p>
         </p:txBody>
@@ -7277,57 +7397,14 @@
       </p:sp>
       <p:sp>
         <p:nvSpPr>
-          <p:cNvPr id="6" name="Rectangle 5"/>
-          <p:cNvSpPr/>
-          <p:nvPr/>
-        </p:nvSpPr>
-        <p:spPr>
-          <a:xfrm>
-            <a:off x="640080" y="2286000"/>
-            <a:ext cx="10881360" cy="3108960"/>
-          </a:xfrm>
-          <a:prstGeom prst="rect">
-            <a:avLst/>
-          </a:prstGeom>
-          <a:solidFill>
-            <a:srgbClr val="1A1A1A"/>
-          </a:solidFill>
-          <a:ln>
-            <a:noFill/>
-          </a:ln>
-        </p:spPr>
-        <p:style>
-          <a:lnRef idx="1">
-            <a:schemeClr val="accent1"/>
-          </a:lnRef>
-          <a:fillRef idx="3">
-            <a:schemeClr val="accent1"/>
-          </a:fillRef>
-          <a:effectRef idx="2">
-            <a:schemeClr val="accent1"/>
-          </a:effectRef>
-          <a:fontRef idx="minor">
-            <a:schemeClr val="lt1"/>
-          </a:fontRef>
-        </p:style>
-        <p:txBody>
-          <a:bodyPr rtlCol="0" anchor="ctr"/>
-          <a:lstStyle/>
-          <a:p>
-            <a:pPr algn="ctr"/>
-          </a:p>
-        </p:txBody>
-      </p:sp>
-      <p:sp>
-        <p:nvSpPr>
-          <p:cNvPr id="7" name="TextBox 6"/>
+          <p:cNvPr id="6" name="TextBox 5"/>
           <p:cNvSpPr txBox="1"/>
           <p:nvPr/>
         </p:nvSpPr>
         <p:spPr>
           <a:xfrm>
-            <a:off x="914400" y="2514600"/>
-            <a:ext cx="10332720" cy="2743200"/>
+            <a:off x="640080" y="2560320"/>
+            <a:ext cx="10881360" cy="3474720"/>
           </a:xfrm>
           <a:prstGeom prst="rect">
             <a:avLst/>
@@ -7342,32 +7419,52 @@
           <a:p>
             <a:pPr algn="l"/>
             <a:r>
-              <a:rPr sz="2000" b="0" i="0">
-                <a:solidFill>
-                  <a:srgbClr val="FFFFFF"/>
-                </a:solidFill>
-                <a:latin typeface="Consolas"/>
-              </a:rPr>
-              <a:t>Adaptador Ethernet Ethernet:</a:t>
-            </a:r>
-          </a:p>
-          <a:p>
-            <a:pPr algn="l"/>
-            <a:r>
-              <a:rPr sz="2000" b="0" i="0">
-                <a:solidFill>
-                  <a:srgbClr val="FFFFFF"/>
-                </a:solidFill>
-                <a:latin typeface="Consolas"/>
-              </a:rPr>
-              <a:t>   Estado da mídia. . . . . . . . . . : mídia desconectada</a:t>
-            </a:r>
-          </a:p>
-        </p:txBody>
-      </p:sp>
-      <p:sp>
-        <p:nvSpPr>
-          <p:cNvPr id="8" name="TextBox 7"/>
+              <a:rPr sz="2200" b="0" i="0">
+                <a:solidFill>
+                  <a:srgbClr val="1A1A1A"/>
+                </a:solidFill>
+              </a:rPr>
+              <a:t>•  Liga o computador por cabo. A luz acende</a:t>
+            </a:r>
+          </a:p>
+          <a:p>
+            <a:pPr algn="l"/>
+            <a:r>
+              <a:rPr sz="2200" b="0" i="0">
+                <a:solidFill>
+                  <a:srgbClr val="1A1A1A"/>
+                </a:solidFill>
+              </a:rPr>
+              <a:t>•  ipconfig — o que aparece?</a:t>
+            </a:r>
+          </a:p>
+          <a:p>
+            <a:pPr algn="l"/>
+            <a:r>
+              <a:rPr sz="2200" b="0" i="0">
+                <a:solidFill>
+                  <a:srgbClr val="1A1A1A"/>
+                </a:solidFill>
+              </a:rPr>
+              <a:t>•  Tenta o celular no Wi-Fi dele — o que acontece?</a:t>
+            </a:r>
+          </a:p>
+          <a:p>
+            <a:pPr algn="l"/>
+            <a:r>
+              <a:rPr sz="2200" b="0" i="0">
+                <a:solidFill>
+                  <a:srgbClr val="1A1A1A"/>
+                </a:solidFill>
+              </a:rPr>
+              <a:t>•  Escreva o diagnóstico</a:t>
+            </a:r>
+          </a:p>
+        </p:txBody>
+      </p:sp>
+      <p:sp>
+        <p:nvSpPr>
+          <p:cNvPr id="7" name="TextBox 6"/>
           <p:cNvSpPr txBox="1"/>
           <p:nvPr/>
         </p:nvSpPr>
@@ -7408,6 +7505,942 @@
 </file>
 
 <file path=ppt/slides/slide24.xml><?xml version="1.0" encoding="utf-8"?>
+<p:sld xmlns:a="http://schemas.openxmlformats.org/drawingml/2006/main" xmlns:p="http://schemas.openxmlformats.org/presentationml/2006/main" xmlns:r="http://schemas.openxmlformats.org/officeDocument/2006/relationships">
+  <p:cSld>
+    <p:spTree>
+      <p:nvGrpSpPr>
+        <p:cNvPr id="1" name=""/>
+        <p:cNvGrpSpPr/>
+        <p:nvPr/>
+      </p:nvGrpSpPr>
+      <p:grpSpPr/>
+      <p:sp>
+        <p:nvSpPr>
+          <p:cNvPr id="2" name="Rectangle 1"/>
+          <p:cNvSpPr/>
+          <p:nvPr/>
+        </p:nvSpPr>
+        <p:spPr>
+          <a:xfrm>
+            <a:off x="0" y="0"/>
+            <a:ext cx="12191695" cy="6858000"/>
+          </a:xfrm>
+          <a:prstGeom prst="rect">
+            <a:avLst/>
+          </a:prstGeom>
+          <a:solidFill>
+            <a:srgbClr val="F4F7F7"/>
+          </a:solidFill>
+          <a:ln>
+            <a:noFill/>
+          </a:ln>
+        </p:spPr>
+        <p:style>
+          <a:lnRef idx="1">
+            <a:schemeClr val="accent1"/>
+          </a:lnRef>
+          <a:fillRef idx="3">
+            <a:schemeClr val="accent1"/>
+          </a:fillRef>
+          <a:effectRef idx="2">
+            <a:schemeClr val="accent1"/>
+          </a:effectRef>
+          <a:fontRef idx="minor">
+            <a:schemeClr val="lt1"/>
+          </a:fontRef>
+        </p:style>
+        <p:txBody>
+          <a:bodyPr rtlCol="0" anchor="ctr"/>
+          <a:lstStyle/>
+          <a:p>
+            <a:pPr algn="ctr"/>
+          </a:p>
+        </p:txBody>
+      </p:sp>
+      <p:sp>
+        <p:nvSpPr>
+          <p:cNvPr id="3" name="TextBox 2"/>
+          <p:cNvSpPr txBox="1"/>
+          <p:nvPr/>
+        </p:nvSpPr>
+        <p:spPr>
+          <a:xfrm>
+            <a:off x="640080" y="365760"/>
+            <a:ext cx="10881360" cy="320040"/>
+          </a:xfrm>
+          <a:prstGeom prst="rect">
+            <a:avLst/>
+          </a:prstGeom>
+          <a:noFill/>
+        </p:spPr>
+        <p:txBody>
+          <a:bodyPr wrap="square" lIns="0" rIns="0" tIns="0" bIns="0" anchor="t">
+            <a:spAutoFit/>
+          </a:bodyPr>
+          <a:lstStyle/>
+          <a:p>
+            <a:pPr algn="l"/>
+            <a:r>
+              <a:rPr sz="1300" b="1" i="0">
+                <a:solidFill>
+                  <a:srgbClr val="E88B1A"/>
+                </a:solidFill>
+              </a:rPr>
+              <a:t>LEIA A TELA</a:t>
+            </a:r>
+          </a:p>
+        </p:txBody>
+      </p:sp>
+      <p:sp>
+        <p:nvSpPr>
+          <p:cNvPr id="4" name="TextBox 3"/>
+          <p:cNvSpPr txBox="1"/>
+          <p:nvPr/>
+        </p:nvSpPr>
+        <p:spPr>
+          <a:xfrm>
+            <a:off x="640080" y="685800"/>
+            <a:ext cx="10881360" cy="822960"/>
+          </a:xfrm>
+          <a:prstGeom prst="rect">
+            <a:avLst/>
+          </a:prstGeom>
+          <a:noFill/>
+        </p:spPr>
+        <p:txBody>
+          <a:bodyPr wrap="square" lIns="0" rIns="0" tIns="0" bIns="0" anchor="t">
+            <a:spAutoFit/>
+          </a:bodyPr>
+          <a:lstStyle/>
+          <a:p>
+            <a:pPr algn="l"/>
+            <a:r>
+              <a:rPr sz="3400" b="1" i="0">
+                <a:solidFill>
+                  <a:srgbClr val="0B5C5C"/>
+                </a:solidFill>
+              </a:rPr>
+              <a:t>Tela A: o que está acontecendo?</a:t>
+            </a:r>
+          </a:p>
+        </p:txBody>
+      </p:sp>
+      <p:sp>
+        <p:nvSpPr>
+          <p:cNvPr id="5" name="Rectangle 4"/>
+          <p:cNvSpPr/>
+          <p:nvPr/>
+        </p:nvSpPr>
+        <p:spPr>
+          <a:xfrm>
+            <a:off x="640080" y="1554480"/>
+            <a:ext cx="10881360" cy="54864"/>
+          </a:xfrm>
+          <a:prstGeom prst="rect">
+            <a:avLst/>
+          </a:prstGeom>
+          <a:solidFill>
+            <a:srgbClr val="0B5C5C"/>
+          </a:solidFill>
+          <a:ln>
+            <a:noFill/>
+          </a:ln>
+        </p:spPr>
+        <p:style>
+          <a:lnRef idx="1">
+            <a:schemeClr val="accent1"/>
+          </a:lnRef>
+          <a:fillRef idx="3">
+            <a:schemeClr val="accent1"/>
+          </a:fillRef>
+          <a:effectRef idx="2">
+            <a:schemeClr val="accent1"/>
+          </a:effectRef>
+          <a:fontRef idx="minor">
+            <a:schemeClr val="lt1"/>
+          </a:fontRef>
+        </p:style>
+        <p:txBody>
+          <a:bodyPr rtlCol="0" anchor="ctr"/>
+          <a:lstStyle/>
+          <a:p>
+            <a:pPr algn="ctr"/>
+          </a:p>
+        </p:txBody>
+      </p:sp>
+      <p:sp>
+        <p:nvSpPr>
+          <p:cNvPr id="6" name="Rectangle 5"/>
+          <p:cNvSpPr/>
+          <p:nvPr/>
+        </p:nvSpPr>
+        <p:spPr>
+          <a:xfrm>
+            <a:off x="640080" y="2286000"/>
+            <a:ext cx="10881360" cy="3108960"/>
+          </a:xfrm>
+          <a:prstGeom prst="rect">
+            <a:avLst/>
+          </a:prstGeom>
+          <a:solidFill>
+            <a:srgbClr val="1A1A1A"/>
+          </a:solidFill>
+          <a:ln>
+            <a:noFill/>
+          </a:ln>
+        </p:spPr>
+        <p:style>
+          <a:lnRef idx="1">
+            <a:schemeClr val="accent1"/>
+          </a:lnRef>
+          <a:fillRef idx="3">
+            <a:schemeClr val="accent1"/>
+          </a:fillRef>
+          <a:effectRef idx="2">
+            <a:schemeClr val="accent1"/>
+          </a:effectRef>
+          <a:fontRef idx="minor">
+            <a:schemeClr val="lt1"/>
+          </a:fontRef>
+        </p:style>
+        <p:txBody>
+          <a:bodyPr rtlCol="0" anchor="ctr"/>
+          <a:lstStyle/>
+          <a:p>
+            <a:pPr algn="ctr"/>
+          </a:p>
+        </p:txBody>
+      </p:sp>
+      <p:sp>
+        <p:nvSpPr>
+          <p:cNvPr id="7" name="TextBox 6"/>
+          <p:cNvSpPr txBox="1"/>
+          <p:nvPr/>
+        </p:nvSpPr>
+        <p:spPr>
+          <a:xfrm>
+            <a:off x="914400" y="2514600"/>
+            <a:ext cx="10332720" cy="2743200"/>
+          </a:xfrm>
+          <a:prstGeom prst="rect">
+            <a:avLst/>
+          </a:prstGeom>
+          <a:noFill/>
+        </p:spPr>
+        <p:txBody>
+          <a:bodyPr wrap="square" lIns="0" rIns="0" tIns="0" bIns="0" anchor="t">
+            <a:spAutoFit/>
+          </a:bodyPr>
+          <a:lstStyle/>
+          <a:p>
+            <a:pPr algn="l"/>
+            <a:r>
+              <a:rPr sz="2000" b="0" i="0">
+                <a:solidFill>
+                  <a:srgbClr val="FFFFFF"/>
+                </a:solidFill>
+                <a:latin typeface="Consolas"/>
+              </a:rPr>
+              <a:t>Adaptador Ethernet Ethernet:</a:t>
+            </a:r>
+          </a:p>
+          <a:p>
+            <a:pPr algn="l"/>
+            <a:r>
+              <a:rPr sz="2000" b="0" i="0">
+                <a:solidFill>
+                  <a:srgbClr val="FFFFFF"/>
+                </a:solidFill>
+                <a:latin typeface="Consolas"/>
+              </a:rPr>
+              <a:t>   Endereço IPv4. . . . . . . . . . . : 192.168.0.104</a:t>
+            </a:r>
+          </a:p>
+          <a:p>
+            <a:pPr algn="l"/>
+            <a:r>
+              <a:rPr sz="2000" b="0" i="0">
+                <a:solidFill>
+                  <a:srgbClr val="FFFFFF"/>
+                </a:solidFill>
+                <a:latin typeface="Consolas"/>
+              </a:rPr>
+              <a:t>   Máscara de Sub-rede . . . . . . . . : 255.255.255.0</a:t>
+            </a:r>
+          </a:p>
+          <a:p>
+            <a:pPr algn="l"/>
+            <a:r>
+              <a:rPr sz="2000" b="0" i="0">
+                <a:solidFill>
+                  <a:srgbClr val="FFFFFF"/>
+                </a:solidFill>
+                <a:latin typeface="Consolas"/>
+              </a:rPr>
+              <a:t>   Gateway Padrão. . . . . . . . . . . : 192.168.0.1</a:t>
+            </a:r>
+          </a:p>
+        </p:txBody>
+      </p:sp>
+      <p:sp>
+        <p:nvSpPr>
+          <p:cNvPr id="8" name="TextBox 7"/>
+          <p:cNvSpPr txBox="1"/>
+          <p:nvPr/>
+        </p:nvSpPr>
+        <p:spPr>
+          <a:xfrm>
+            <a:off x="640080" y="6446520"/>
+            <a:ext cx="10881360" cy="274320"/>
+          </a:xfrm>
+          <a:prstGeom prst="rect">
+            <a:avLst/>
+          </a:prstGeom>
+          <a:noFill/>
+        </p:spPr>
+        <p:txBody>
+          <a:bodyPr wrap="square" lIns="0" rIns="0" tIns="0" bIns="0" anchor="t">
+            <a:spAutoFit/>
+          </a:bodyPr>
+          <a:lstStyle/>
+          <a:p>
+            <a:pPr algn="l"/>
+            <a:r>
+              <a:rPr sz="1000" b="0" i="1">
+                <a:solidFill>
+                  <a:srgbClr val="555555"/>
+                </a:solidFill>
+              </a:rPr>
+              <a:t>Redes de Computadores · Noite 6</a:t>
+            </a:r>
+          </a:p>
+        </p:txBody>
+      </p:sp>
+    </p:spTree>
+  </p:cSld>
+  <p:clrMapOvr>
+    <a:masterClrMapping/>
+  </p:clrMapOvr>
+</p:sld>
+</file>
+
+<file path=ppt/slides/slide25.xml><?xml version="1.0" encoding="utf-8"?>
+<p:sld xmlns:a="http://schemas.openxmlformats.org/drawingml/2006/main" xmlns:p="http://schemas.openxmlformats.org/presentationml/2006/main" xmlns:r="http://schemas.openxmlformats.org/officeDocument/2006/relationships">
+  <p:cSld>
+    <p:spTree>
+      <p:nvGrpSpPr>
+        <p:cNvPr id="1" name=""/>
+        <p:cNvGrpSpPr/>
+        <p:nvPr/>
+      </p:nvGrpSpPr>
+      <p:grpSpPr/>
+      <p:sp>
+        <p:nvSpPr>
+          <p:cNvPr id="2" name="Rectangle 1"/>
+          <p:cNvSpPr/>
+          <p:nvPr/>
+        </p:nvSpPr>
+        <p:spPr>
+          <a:xfrm>
+            <a:off x="0" y="0"/>
+            <a:ext cx="12191695" cy="6858000"/>
+          </a:xfrm>
+          <a:prstGeom prst="rect">
+            <a:avLst/>
+          </a:prstGeom>
+          <a:solidFill>
+            <a:srgbClr val="F4F7F7"/>
+          </a:solidFill>
+          <a:ln>
+            <a:noFill/>
+          </a:ln>
+        </p:spPr>
+        <p:style>
+          <a:lnRef idx="1">
+            <a:schemeClr val="accent1"/>
+          </a:lnRef>
+          <a:fillRef idx="3">
+            <a:schemeClr val="accent1"/>
+          </a:fillRef>
+          <a:effectRef idx="2">
+            <a:schemeClr val="accent1"/>
+          </a:effectRef>
+          <a:fontRef idx="minor">
+            <a:schemeClr val="lt1"/>
+          </a:fontRef>
+        </p:style>
+        <p:txBody>
+          <a:bodyPr rtlCol="0" anchor="ctr"/>
+          <a:lstStyle/>
+          <a:p>
+            <a:pPr algn="ctr"/>
+          </a:p>
+        </p:txBody>
+      </p:sp>
+      <p:sp>
+        <p:nvSpPr>
+          <p:cNvPr id="3" name="TextBox 2"/>
+          <p:cNvSpPr txBox="1"/>
+          <p:nvPr/>
+        </p:nvSpPr>
+        <p:spPr>
+          <a:xfrm>
+            <a:off x="640080" y="365760"/>
+            <a:ext cx="10881360" cy="320040"/>
+          </a:xfrm>
+          <a:prstGeom prst="rect">
+            <a:avLst/>
+          </a:prstGeom>
+          <a:noFill/>
+        </p:spPr>
+        <p:txBody>
+          <a:bodyPr wrap="square" lIns="0" rIns="0" tIns="0" bIns="0" anchor="t">
+            <a:spAutoFit/>
+          </a:bodyPr>
+          <a:lstStyle/>
+          <a:p>
+            <a:pPr algn="l"/>
+            <a:r>
+              <a:rPr sz="1300" b="1" i="0">
+                <a:solidFill>
+                  <a:srgbClr val="E88B1A"/>
+                </a:solidFill>
+              </a:rPr>
+              <a:t>LEIA A TELA</a:t>
+            </a:r>
+          </a:p>
+        </p:txBody>
+      </p:sp>
+      <p:sp>
+        <p:nvSpPr>
+          <p:cNvPr id="4" name="TextBox 3"/>
+          <p:cNvSpPr txBox="1"/>
+          <p:nvPr/>
+        </p:nvSpPr>
+        <p:spPr>
+          <a:xfrm>
+            <a:off x="640080" y="685800"/>
+            <a:ext cx="10881360" cy="822960"/>
+          </a:xfrm>
+          <a:prstGeom prst="rect">
+            <a:avLst/>
+          </a:prstGeom>
+          <a:noFill/>
+        </p:spPr>
+        <p:txBody>
+          <a:bodyPr wrap="square" lIns="0" rIns="0" tIns="0" bIns="0" anchor="t">
+            <a:spAutoFit/>
+          </a:bodyPr>
+          <a:lstStyle/>
+          <a:p>
+            <a:pPr algn="l"/>
+            <a:r>
+              <a:rPr sz="3400" b="1" i="0">
+                <a:solidFill>
+                  <a:srgbClr val="0B5C5C"/>
+                </a:solidFill>
+              </a:rPr>
+              <a:t>Tela B: o que está acontecendo?</a:t>
+            </a:r>
+          </a:p>
+        </p:txBody>
+      </p:sp>
+      <p:sp>
+        <p:nvSpPr>
+          <p:cNvPr id="5" name="Rectangle 4"/>
+          <p:cNvSpPr/>
+          <p:nvPr/>
+        </p:nvSpPr>
+        <p:spPr>
+          <a:xfrm>
+            <a:off x="640080" y="1554480"/>
+            <a:ext cx="10881360" cy="54864"/>
+          </a:xfrm>
+          <a:prstGeom prst="rect">
+            <a:avLst/>
+          </a:prstGeom>
+          <a:solidFill>
+            <a:srgbClr val="0B5C5C"/>
+          </a:solidFill>
+          <a:ln>
+            <a:noFill/>
+          </a:ln>
+        </p:spPr>
+        <p:style>
+          <a:lnRef idx="1">
+            <a:schemeClr val="accent1"/>
+          </a:lnRef>
+          <a:fillRef idx="3">
+            <a:schemeClr val="accent1"/>
+          </a:fillRef>
+          <a:effectRef idx="2">
+            <a:schemeClr val="accent1"/>
+          </a:effectRef>
+          <a:fontRef idx="minor">
+            <a:schemeClr val="lt1"/>
+          </a:fontRef>
+        </p:style>
+        <p:txBody>
+          <a:bodyPr rtlCol="0" anchor="ctr"/>
+          <a:lstStyle/>
+          <a:p>
+            <a:pPr algn="ctr"/>
+          </a:p>
+        </p:txBody>
+      </p:sp>
+      <p:sp>
+        <p:nvSpPr>
+          <p:cNvPr id="6" name="Rectangle 5"/>
+          <p:cNvSpPr/>
+          <p:nvPr/>
+        </p:nvSpPr>
+        <p:spPr>
+          <a:xfrm>
+            <a:off x="640080" y="2286000"/>
+            <a:ext cx="10881360" cy="3108960"/>
+          </a:xfrm>
+          <a:prstGeom prst="rect">
+            <a:avLst/>
+          </a:prstGeom>
+          <a:solidFill>
+            <a:srgbClr val="1A1A1A"/>
+          </a:solidFill>
+          <a:ln>
+            <a:noFill/>
+          </a:ln>
+        </p:spPr>
+        <p:style>
+          <a:lnRef idx="1">
+            <a:schemeClr val="accent1"/>
+          </a:lnRef>
+          <a:fillRef idx="3">
+            <a:schemeClr val="accent1"/>
+          </a:fillRef>
+          <a:effectRef idx="2">
+            <a:schemeClr val="accent1"/>
+          </a:effectRef>
+          <a:fontRef idx="minor">
+            <a:schemeClr val="lt1"/>
+          </a:fontRef>
+        </p:style>
+        <p:txBody>
+          <a:bodyPr rtlCol="0" anchor="ctr"/>
+          <a:lstStyle/>
+          <a:p>
+            <a:pPr algn="ctr"/>
+          </a:p>
+        </p:txBody>
+      </p:sp>
+      <p:sp>
+        <p:nvSpPr>
+          <p:cNvPr id="7" name="TextBox 6"/>
+          <p:cNvSpPr txBox="1"/>
+          <p:nvPr/>
+        </p:nvSpPr>
+        <p:spPr>
+          <a:xfrm>
+            <a:off x="914400" y="2514600"/>
+            <a:ext cx="10332720" cy="2743200"/>
+          </a:xfrm>
+          <a:prstGeom prst="rect">
+            <a:avLst/>
+          </a:prstGeom>
+          <a:noFill/>
+        </p:spPr>
+        <p:txBody>
+          <a:bodyPr wrap="square" lIns="0" rIns="0" tIns="0" bIns="0" anchor="t">
+            <a:spAutoFit/>
+          </a:bodyPr>
+          <a:lstStyle/>
+          <a:p>
+            <a:pPr algn="l"/>
+            <a:r>
+              <a:rPr sz="2000" b="0" i="0">
+                <a:solidFill>
+                  <a:srgbClr val="FFFFFF"/>
+                </a:solidFill>
+                <a:latin typeface="Consolas"/>
+              </a:rPr>
+              <a:t>Adaptador Ethernet Ethernet:</a:t>
+            </a:r>
+          </a:p>
+          <a:p>
+            <a:pPr algn="l"/>
+            <a:r>
+              <a:rPr sz="2000" b="0" i="0">
+                <a:solidFill>
+                  <a:srgbClr val="FFFFFF"/>
+                </a:solidFill>
+                <a:latin typeface="Consolas"/>
+              </a:rPr>
+              <a:t>   Endereço IPv4 de Configuração Automática: 169.254.37.112</a:t>
+            </a:r>
+          </a:p>
+          <a:p>
+            <a:pPr algn="l"/>
+            <a:r>
+              <a:rPr sz="2000" b="0" i="0">
+                <a:solidFill>
+                  <a:srgbClr val="FFFFFF"/>
+                </a:solidFill>
+                <a:latin typeface="Consolas"/>
+              </a:rPr>
+              <a:t>   Máscara de Sub-rede . . . . . . . . : 255.255.0.0</a:t>
+            </a:r>
+          </a:p>
+          <a:p>
+            <a:pPr algn="l"/>
+            <a:r>
+              <a:rPr sz="2000" b="0" i="0">
+                <a:solidFill>
+                  <a:srgbClr val="FFFFFF"/>
+                </a:solidFill>
+                <a:latin typeface="Consolas"/>
+              </a:rPr>
+              <a:t>   Gateway Padrão. . . . . . . . . . . :</a:t>
+            </a:r>
+          </a:p>
+        </p:txBody>
+      </p:sp>
+      <p:sp>
+        <p:nvSpPr>
+          <p:cNvPr id="8" name="TextBox 7"/>
+          <p:cNvSpPr txBox="1"/>
+          <p:nvPr/>
+        </p:nvSpPr>
+        <p:spPr>
+          <a:xfrm>
+            <a:off x="640080" y="6446520"/>
+            <a:ext cx="10881360" cy="274320"/>
+          </a:xfrm>
+          <a:prstGeom prst="rect">
+            <a:avLst/>
+          </a:prstGeom>
+          <a:noFill/>
+        </p:spPr>
+        <p:txBody>
+          <a:bodyPr wrap="square" lIns="0" rIns="0" tIns="0" bIns="0" anchor="t">
+            <a:spAutoFit/>
+          </a:bodyPr>
+          <a:lstStyle/>
+          <a:p>
+            <a:pPr algn="l"/>
+            <a:r>
+              <a:rPr sz="1000" b="0" i="1">
+                <a:solidFill>
+                  <a:srgbClr val="555555"/>
+                </a:solidFill>
+              </a:rPr>
+              <a:t>Redes de Computadores · Noite 6</a:t>
+            </a:r>
+          </a:p>
+        </p:txBody>
+      </p:sp>
+    </p:spTree>
+  </p:cSld>
+  <p:clrMapOvr>
+    <a:masterClrMapping/>
+  </p:clrMapOvr>
+</p:sld>
+</file>
+
+<file path=ppt/slides/slide26.xml><?xml version="1.0" encoding="utf-8"?>
+<p:sld xmlns:a="http://schemas.openxmlformats.org/drawingml/2006/main" xmlns:p="http://schemas.openxmlformats.org/presentationml/2006/main" xmlns:r="http://schemas.openxmlformats.org/officeDocument/2006/relationships">
+  <p:cSld>
+    <p:spTree>
+      <p:nvGrpSpPr>
+        <p:cNvPr id="1" name=""/>
+        <p:cNvGrpSpPr/>
+        <p:nvPr/>
+      </p:nvGrpSpPr>
+      <p:grpSpPr/>
+      <p:sp>
+        <p:nvSpPr>
+          <p:cNvPr id="2" name="Rectangle 1"/>
+          <p:cNvSpPr/>
+          <p:nvPr/>
+        </p:nvSpPr>
+        <p:spPr>
+          <a:xfrm>
+            <a:off x="0" y="0"/>
+            <a:ext cx="12191695" cy="6858000"/>
+          </a:xfrm>
+          <a:prstGeom prst="rect">
+            <a:avLst/>
+          </a:prstGeom>
+          <a:solidFill>
+            <a:srgbClr val="F4F7F7"/>
+          </a:solidFill>
+          <a:ln>
+            <a:noFill/>
+          </a:ln>
+        </p:spPr>
+        <p:style>
+          <a:lnRef idx="1">
+            <a:schemeClr val="accent1"/>
+          </a:lnRef>
+          <a:fillRef idx="3">
+            <a:schemeClr val="accent1"/>
+          </a:fillRef>
+          <a:effectRef idx="2">
+            <a:schemeClr val="accent1"/>
+          </a:effectRef>
+          <a:fontRef idx="minor">
+            <a:schemeClr val="lt1"/>
+          </a:fontRef>
+        </p:style>
+        <p:txBody>
+          <a:bodyPr rtlCol="0" anchor="ctr"/>
+          <a:lstStyle/>
+          <a:p>
+            <a:pPr algn="ctr"/>
+          </a:p>
+        </p:txBody>
+      </p:sp>
+      <p:sp>
+        <p:nvSpPr>
+          <p:cNvPr id="3" name="TextBox 2"/>
+          <p:cNvSpPr txBox="1"/>
+          <p:nvPr/>
+        </p:nvSpPr>
+        <p:spPr>
+          <a:xfrm>
+            <a:off x="640080" y="365760"/>
+            <a:ext cx="10881360" cy="320040"/>
+          </a:xfrm>
+          <a:prstGeom prst="rect">
+            <a:avLst/>
+          </a:prstGeom>
+          <a:noFill/>
+        </p:spPr>
+        <p:txBody>
+          <a:bodyPr wrap="square" lIns="0" rIns="0" tIns="0" bIns="0" anchor="t">
+            <a:spAutoFit/>
+          </a:bodyPr>
+          <a:lstStyle/>
+          <a:p>
+            <a:pPr algn="l"/>
+            <a:r>
+              <a:rPr sz="1300" b="1" i="0">
+                <a:solidFill>
+                  <a:srgbClr val="E88B1A"/>
+                </a:solidFill>
+              </a:rPr>
+              <a:t>LEIA A TELA</a:t>
+            </a:r>
+          </a:p>
+        </p:txBody>
+      </p:sp>
+      <p:sp>
+        <p:nvSpPr>
+          <p:cNvPr id="4" name="TextBox 3"/>
+          <p:cNvSpPr txBox="1"/>
+          <p:nvPr/>
+        </p:nvSpPr>
+        <p:spPr>
+          <a:xfrm>
+            <a:off x="640080" y="685800"/>
+            <a:ext cx="10881360" cy="822960"/>
+          </a:xfrm>
+          <a:prstGeom prst="rect">
+            <a:avLst/>
+          </a:prstGeom>
+          <a:noFill/>
+        </p:spPr>
+        <p:txBody>
+          <a:bodyPr wrap="square" lIns="0" rIns="0" tIns="0" bIns="0" anchor="t">
+            <a:spAutoFit/>
+          </a:bodyPr>
+          <a:lstStyle/>
+          <a:p>
+            <a:pPr algn="l"/>
+            <a:r>
+              <a:rPr sz="3400" b="1" i="0">
+                <a:solidFill>
+                  <a:srgbClr val="0B5C5C"/>
+                </a:solidFill>
+              </a:rPr>
+              <a:t>Tela C: o que está acontecendo?</a:t>
+            </a:r>
+          </a:p>
+        </p:txBody>
+      </p:sp>
+      <p:sp>
+        <p:nvSpPr>
+          <p:cNvPr id="5" name="Rectangle 4"/>
+          <p:cNvSpPr/>
+          <p:nvPr/>
+        </p:nvSpPr>
+        <p:spPr>
+          <a:xfrm>
+            <a:off x="640080" y="1554480"/>
+            <a:ext cx="10881360" cy="54864"/>
+          </a:xfrm>
+          <a:prstGeom prst="rect">
+            <a:avLst/>
+          </a:prstGeom>
+          <a:solidFill>
+            <a:srgbClr val="0B5C5C"/>
+          </a:solidFill>
+          <a:ln>
+            <a:noFill/>
+          </a:ln>
+        </p:spPr>
+        <p:style>
+          <a:lnRef idx="1">
+            <a:schemeClr val="accent1"/>
+          </a:lnRef>
+          <a:fillRef idx="3">
+            <a:schemeClr val="accent1"/>
+          </a:fillRef>
+          <a:effectRef idx="2">
+            <a:schemeClr val="accent1"/>
+          </a:effectRef>
+          <a:fontRef idx="minor">
+            <a:schemeClr val="lt1"/>
+          </a:fontRef>
+        </p:style>
+        <p:txBody>
+          <a:bodyPr rtlCol="0" anchor="ctr"/>
+          <a:lstStyle/>
+          <a:p>
+            <a:pPr algn="ctr"/>
+          </a:p>
+        </p:txBody>
+      </p:sp>
+      <p:sp>
+        <p:nvSpPr>
+          <p:cNvPr id="6" name="Rectangle 5"/>
+          <p:cNvSpPr/>
+          <p:nvPr/>
+        </p:nvSpPr>
+        <p:spPr>
+          <a:xfrm>
+            <a:off x="640080" y="2286000"/>
+            <a:ext cx="10881360" cy="3108960"/>
+          </a:xfrm>
+          <a:prstGeom prst="rect">
+            <a:avLst/>
+          </a:prstGeom>
+          <a:solidFill>
+            <a:srgbClr val="1A1A1A"/>
+          </a:solidFill>
+          <a:ln>
+            <a:noFill/>
+          </a:ln>
+        </p:spPr>
+        <p:style>
+          <a:lnRef idx="1">
+            <a:schemeClr val="accent1"/>
+          </a:lnRef>
+          <a:fillRef idx="3">
+            <a:schemeClr val="accent1"/>
+          </a:fillRef>
+          <a:effectRef idx="2">
+            <a:schemeClr val="accent1"/>
+          </a:effectRef>
+          <a:fontRef idx="minor">
+            <a:schemeClr val="lt1"/>
+          </a:fontRef>
+        </p:style>
+        <p:txBody>
+          <a:bodyPr rtlCol="0" anchor="ctr"/>
+          <a:lstStyle/>
+          <a:p>
+            <a:pPr algn="ctr"/>
+          </a:p>
+        </p:txBody>
+      </p:sp>
+      <p:sp>
+        <p:nvSpPr>
+          <p:cNvPr id="7" name="TextBox 6"/>
+          <p:cNvSpPr txBox="1"/>
+          <p:nvPr/>
+        </p:nvSpPr>
+        <p:spPr>
+          <a:xfrm>
+            <a:off x="914400" y="2514600"/>
+            <a:ext cx="10332720" cy="2743200"/>
+          </a:xfrm>
+          <a:prstGeom prst="rect">
+            <a:avLst/>
+          </a:prstGeom>
+          <a:noFill/>
+        </p:spPr>
+        <p:txBody>
+          <a:bodyPr wrap="square" lIns="0" rIns="0" tIns="0" bIns="0" anchor="t">
+            <a:spAutoFit/>
+          </a:bodyPr>
+          <a:lstStyle/>
+          <a:p>
+            <a:pPr algn="l"/>
+            <a:r>
+              <a:rPr sz="2000" b="0" i="0">
+                <a:solidFill>
+                  <a:srgbClr val="FFFFFF"/>
+                </a:solidFill>
+                <a:latin typeface="Consolas"/>
+              </a:rPr>
+              <a:t>Adaptador Ethernet Ethernet:</a:t>
+            </a:r>
+          </a:p>
+          <a:p>
+            <a:pPr algn="l"/>
+            <a:r>
+              <a:rPr sz="2000" b="0" i="0">
+                <a:solidFill>
+                  <a:srgbClr val="FFFFFF"/>
+                </a:solidFill>
+                <a:latin typeface="Consolas"/>
+              </a:rPr>
+              <a:t>   Estado da mídia. . . . . . . . . . : mídia desconectada</a:t>
+            </a:r>
+          </a:p>
+        </p:txBody>
+      </p:sp>
+      <p:sp>
+        <p:nvSpPr>
+          <p:cNvPr id="8" name="TextBox 7"/>
+          <p:cNvSpPr txBox="1"/>
+          <p:nvPr/>
+        </p:nvSpPr>
+        <p:spPr>
+          <a:xfrm>
+            <a:off x="640080" y="6446520"/>
+            <a:ext cx="10881360" cy="274320"/>
+          </a:xfrm>
+          <a:prstGeom prst="rect">
+            <a:avLst/>
+          </a:prstGeom>
+          <a:noFill/>
+        </p:spPr>
+        <p:txBody>
+          <a:bodyPr wrap="square" lIns="0" rIns="0" tIns="0" bIns="0" anchor="t">
+            <a:spAutoFit/>
+          </a:bodyPr>
+          <a:lstStyle/>
+          <a:p>
+            <a:pPr algn="l"/>
+            <a:r>
+              <a:rPr sz="1000" b="0" i="1">
+                <a:solidFill>
+                  <a:srgbClr val="555555"/>
+                </a:solidFill>
+              </a:rPr>
+              <a:t>Redes de Computadores · Noite 6</a:t>
+            </a:r>
+          </a:p>
+        </p:txBody>
+      </p:sp>
+    </p:spTree>
+  </p:cSld>
+  <p:clrMapOvr>
+    <a:masterClrMapping/>
+  </p:clrMapOvr>
+</p:sld>
+</file>
+
+<file path=ppt/slides/slide27.xml><?xml version="1.0" encoding="utf-8"?>
 <p:sld xmlns:a="http://schemas.openxmlformats.org/drawingml/2006/main" xmlns:p="http://schemas.openxmlformats.org/presentationml/2006/main" xmlns:r="http://schemas.openxmlformats.org/officeDocument/2006/relationships">
   <p:cSld>
     <p:spTree>
@@ -7864,859 +8897,6 @@
 </p:sld>
 </file>
 
-<file path=ppt/slides/slide25.xml><?xml version="1.0" encoding="utf-8"?>
-<p:sld xmlns:a="http://schemas.openxmlformats.org/drawingml/2006/main" xmlns:p="http://schemas.openxmlformats.org/presentationml/2006/main" xmlns:r="http://schemas.openxmlformats.org/officeDocument/2006/relationships">
-  <p:cSld>
-    <p:spTree>
-      <p:nvGrpSpPr>
-        <p:cNvPr id="1" name=""/>
-        <p:cNvGrpSpPr/>
-        <p:nvPr/>
-      </p:nvGrpSpPr>
-      <p:grpSpPr/>
-      <p:sp>
-        <p:nvSpPr>
-          <p:cNvPr id="2" name="Rectangle 1"/>
-          <p:cNvSpPr/>
-          <p:nvPr/>
-        </p:nvSpPr>
-        <p:spPr>
-          <a:xfrm>
-            <a:off x="0" y="0"/>
-            <a:ext cx="12191695" cy="6858000"/>
-          </a:xfrm>
-          <a:prstGeom prst="rect">
-            <a:avLst/>
-          </a:prstGeom>
-          <a:solidFill>
-            <a:srgbClr val="F4F7F7"/>
-          </a:solidFill>
-          <a:ln>
-            <a:noFill/>
-          </a:ln>
-        </p:spPr>
-        <p:style>
-          <a:lnRef idx="1">
-            <a:schemeClr val="accent1"/>
-          </a:lnRef>
-          <a:fillRef idx="3">
-            <a:schemeClr val="accent1"/>
-          </a:fillRef>
-          <a:effectRef idx="2">
-            <a:schemeClr val="accent1"/>
-          </a:effectRef>
-          <a:fontRef idx="minor">
-            <a:schemeClr val="lt1"/>
-          </a:fontRef>
-        </p:style>
-        <p:txBody>
-          <a:bodyPr rtlCol="0" anchor="ctr"/>
-          <a:lstStyle/>
-          <a:p>
-            <a:pPr algn="ctr"/>
-          </a:p>
-        </p:txBody>
-      </p:sp>
-      <p:sp>
-        <p:nvSpPr>
-          <p:cNvPr id="3" name="TextBox 2"/>
-          <p:cNvSpPr txBox="1"/>
-          <p:nvPr/>
-        </p:nvSpPr>
-        <p:spPr>
-          <a:xfrm>
-            <a:off x="640080" y="365760"/>
-            <a:ext cx="10881360" cy="320040"/>
-          </a:xfrm>
-          <a:prstGeom prst="rect">
-            <a:avLst/>
-          </a:prstGeom>
-          <a:noFill/>
-        </p:spPr>
-        <p:txBody>
-          <a:bodyPr wrap="square" lIns="0" rIns="0" tIns="0" bIns="0" anchor="t">
-            <a:spAutoFit/>
-          </a:bodyPr>
-          <a:lstStyle/>
-          <a:p>
-            <a:pPr algn="l"/>
-            <a:r>
-              <a:rPr sz="1300" b="1" i="0">
-                <a:solidFill>
-                  <a:srgbClr val="E88B1A"/>
-                </a:solidFill>
-              </a:rPr>
-              <a:t>ROLE-PLAY · 20 MIN</a:t>
-            </a:r>
-          </a:p>
-        </p:txBody>
-      </p:sp>
-      <p:sp>
-        <p:nvSpPr>
-          <p:cNvPr id="4" name="TextBox 3"/>
-          <p:cNvSpPr txBox="1"/>
-          <p:nvPr/>
-        </p:nvSpPr>
-        <p:spPr>
-          <a:xfrm>
-            <a:off x="640080" y="685800"/>
-            <a:ext cx="10881360" cy="822960"/>
-          </a:xfrm>
-          <a:prstGeom prst="rect">
-            <a:avLst/>
-          </a:prstGeom>
-          <a:noFill/>
-        </p:spPr>
-        <p:txBody>
-          <a:bodyPr wrap="square" lIns="0" rIns="0" tIns="0" bIns="0" anchor="t">
-            <a:spAutoFit/>
-          </a:bodyPr>
-          <a:lstStyle/>
-          <a:p>
-            <a:pPr algn="l"/>
-            <a:r>
-              <a:rPr sz="3400" b="1" i="0">
-                <a:solidFill>
-                  <a:srgbClr val="0B5C5C"/>
-                </a:solidFill>
-              </a:rPr>
-              <a:t>Chamados</a:t>
-            </a:r>
-          </a:p>
-        </p:txBody>
-      </p:sp>
-      <p:sp>
-        <p:nvSpPr>
-          <p:cNvPr id="5" name="Rectangle 4"/>
-          <p:cNvSpPr/>
-          <p:nvPr/>
-        </p:nvSpPr>
-        <p:spPr>
-          <a:xfrm>
-            <a:off x="640080" y="1554480"/>
-            <a:ext cx="10881360" cy="54864"/>
-          </a:xfrm>
-          <a:prstGeom prst="rect">
-            <a:avLst/>
-          </a:prstGeom>
-          <a:solidFill>
-            <a:srgbClr val="0B5C5C"/>
-          </a:solidFill>
-          <a:ln>
-            <a:noFill/>
-          </a:ln>
-        </p:spPr>
-        <p:style>
-          <a:lnRef idx="1">
-            <a:schemeClr val="accent1"/>
-          </a:lnRef>
-          <a:fillRef idx="3">
-            <a:schemeClr val="accent1"/>
-          </a:fillRef>
-          <a:effectRef idx="2">
-            <a:schemeClr val="accent1"/>
-          </a:effectRef>
-          <a:fontRef idx="minor">
-            <a:schemeClr val="lt1"/>
-          </a:fontRef>
-        </p:style>
-        <p:txBody>
-          <a:bodyPr rtlCol="0" anchor="ctr"/>
-          <a:lstStyle/>
-          <a:p>
-            <a:pPr algn="ctr"/>
-          </a:p>
-        </p:txBody>
-      </p:sp>
-      <p:sp>
-        <p:nvSpPr>
-          <p:cNvPr id="6" name="TextBox 5"/>
-          <p:cNvSpPr txBox="1"/>
-          <p:nvPr/>
-        </p:nvSpPr>
-        <p:spPr>
-          <a:xfrm>
-            <a:off x="640080" y="2560320"/>
-            <a:ext cx="10881360" cy="3474720"/>
-          </a:xfrm>
-          <a:prstGeom prst="rect">
-            <a:avLst/>
-          </a:prstGeom>
-          <a:noFill/>
-        </p:spPr>
-        <p:txBody>
-          <a:bodyPr wrap="square" lIns="0" rIns="0" tIns="0" bIns="0" anchor="t">
-            <a:spAutoFit/>
-          </a:bodyPr>
-          <a:lstStyle/>
-          <a:p>
-            <a:pPr algn="l"/>
-            <a:r>
-              <a:rPr sz="1900" b="0" i="0">
-                <a:solidFill>
-                  <a:srgbClr val="1A1A1A"/>
-                </a:solidFill>
-              </a:rPr>
-              <a:t>•  "Conectado, sem internet. O cabo é novo, a luz acende."</a:t>
-            </a:r>
-          </a:p>
-          <a:p>
-            <a:pPr algn="l"/>
-            <a:r>
-              <a:rPr sz="1900" b="0" i="0">
-                <a:solidFill>
-                  <a:srgbClr val="1A1A1A"/>
-                </a:solidFill>
-              </a:rPr>
-              <a:t>•  "Faltou luz ontem e a impressora sumiu do computador."</a:t>
-            </a:r>
-          </a:p>
-          <a:p>
-            <a:pPr algn="l"/>
-            <a:r>
-              <a:rPr sz="1900" b="0" i="0">
-                <a:solidFill>
-                  <a:srgbClr val="1A1A1A"/>
-                </a:solidFill>
-              </a:rPr>
-              <a:t>•  "Acho que o vizinho está usando meu Wi-Fi."</a:t>
-            </a:r>
-          </a:p>
-          <a:p>
-            <a:pPr algn="l"/>
-            <a:r>
-              <a:rPr sz="1900" b="0" i="0">
-                <a:solidFill>
-                  <a:srgbClr val="1A1A1A"/>
-                </a:solidFill>
-              </a:rPr>
-              <a:t>•  "Meu filho disse que o IP dele vazou no jogo."</a:t>
-            </a:r>
-          </a:p>
-        </p:txBody>
-      </p:sp>
-      <p:sp>
-        <p:nvSpPr>
-          <p:cNvPr id="7" name="TextBox 6"/>
-          <p:cNvSpPr txBox="1"/>
-          <p:nvPr/>
-        </p:nvSpPr>
-        <p:spPr>
-          <a:xfrm>
-            <a:off x="640080" y="5852160"/>
-            <a:ext cx="10881360" cy="457200"/>
-          </a:xfrm>
-          <a:prstGeom prst="rect">
-            <a:avLst/>
-          </a:prstGeom>
-          <a:noFill/>
-        </p:spPr>
-        <p:txBody>
-          <a:bodyPr wrap="square" lIns="0" rIns="0" tIns="0" bIns="0" anchor="t">
-            <a:spAutoFit/>
-          </a:bodyPr>
-          <a:lstStyle/>
-          <a:p>
-            <a:pPr algn="ctr"/>
-            <a:r>
-              <a:rPr sz="1600" b="0" i="1">
-                <a:solidFill>
-                  <a:srgbClr val="E88B1A"/>
-                </a:solidFill>
-              </a:rPr>
-              <a:t>Técnico: o que você olha primeiro? E depois?</a:t>
-            </a:r>
-          </a:p>
-        </p:txBody>
-      </p:sp>
-      <p:sp>
-        <p:nvSpPr>
-          <p:cNvPr id="8" name="TextBox 7"/>
-          <p:cNvSpPr txBox="1"/>
-          <p:nvPr/>
-        </p:nvSpPr>
-        <p:spPr>
-          <a:xfrm>
-            <a:off x="640080" y="6446520"/>
-            <a:ext cx="10881360" cy="274320"/>
-          </a:xfrm>
-          <a:prstGeom prst="rect">
-            <a:avLst/>
-          </a:prstGeom>
-          <a:noFill/>
-        </p:spPr>
-        <p:txBody>
-          <a:bodyPr wrap="square" lIns="0" rIns="0" tIns="0" bIns="0" anchor="t">
-            <a:spAutoFit/>
-          </a:bodyPr>
-          <a:lstStyle/>
-          <a:p>
-            <a:pPr algn="l"/>
-            <a:r>
-              <a:rPr sz="1000" b="0" i="1">
-                <a:solidFill>
-                  <a:srgbClr val="555555"/>
-                </a:solidFill>
-              </a:rPr>
-              <a:t>Redes de Computadores · Noite 6</a:t>
-            </a:r>
-          </a:p>
-        </p:txBody>
-      </p:sp>
-    </p:spTree>
-  </p:cSld>
-  <p:clrMapOvr>
-    <a:masterClrMapping/>
-  </p:clrMapOvr>
-</p:sld>
-</file>
-
-<file path=ppt/slides/slide26.xml><?xml version="1.0" encoding="utf-8"?>
-<p:sld xmlns:a="http://schemas.openxmlformats.org/drawingml/2006/main" xmlns:p="http://schemas.openxmlformats.org/presentationml/2006/main" xmlns:r="http://schemas.openxmlformats.org/officeDocument/2006/relationships">
-  <p:cSld>
-    <p:spTree>
-      <p:nvGrpSpPr>
-        <p:cNvPr id="1" name=""/>
-        <p:cNvGrpSpPr/>
-        <p:nvPr/>
-      </p:nvGrpSpPr>
-      <p:grpSpPr/>
-      <p:sp>
-        <p:nvSpPr>
-          <p:cNvPr id="2" name="Rectangle 1"/>
-          <p:cNvSpPr/>
-          <p:nvPr/>
-        </p:nvSpPr>
-        <p:spPr>
-          <a:xfrm>
-            <a:off x="0" y="0"/>
-            <a:ext cx="12191695" cy="6858000"/>
-          </a:xfrm>
-          <a:prstGeom prst="rect">
-            <a:avLst/>
-          </a:prstGeom>
-          <a:solidFill>
-            <a:srgbClr val="F4F7F7"/>
-          </a:solidFill>
-          <a:ln>
-            <a:noFill/>
-          </a:ln>
-        </p:spPr>
-        <p:style>
-          <a:lnRef idx="1">
-            <a:schemeClr val="accent1"/>
-          </a:lnRef>
-          <a:fillRef idx="3">
-            <a:schemeClr val="accent1"/>
-          </a:fillRef>
-          <a:effectRef idx="2">
-            <a:schemeClr val="accent1"/>
-          </a:effectRef>
-          <a:fontRef idx="minor">
-            <a:schemeClr val="lt1"/>
-          </a:fontRef>
-        </p:style>
-        <p:txBody>
-          <a:bodyPr rtlCol="0" anchor="ctr"/>
-          <a:lstStyle/>
-          <a:p>
-            <a:pPr algn="ctr"/>
-          </a:p>
-        </p:txBody>
-      </p:sp>
-      <p:sp>
-        <p:nvSpPr>
-          <p:cNvPr id="3" name="TextBox 2"/>
-          <p:cNvSpPr txBox="1"/>
-          <p:nvPr/>
-        </p:nvSpPr>
-        <p:spPr>
-          <a:xfrm>
-            <a:off x="640080" y="365760"/>
-            <a:ext cx="10881360" cy="320040"/>
-          </a:xfrm>
-          <a:prstGeom prst="rect">
-            <a:avLst/>
-          </a:prstGeom>
-          <a:noFill/>
-        </p:spPr>
-        <p:txBody>
-          <a:bodyPr wrap="square" lIns="0" rIns="0" tIns="0" bIns="0" anchor="t">
-            <a:spAutoFit/>
-          </a:bodyPr>
-          <a:lstStyle/>
-          <a:p>
-            <a:pPr algn="l"/>
-            <a:r>
-              <a:rPr sz="1300" b="1" i="0">
-                <a:solidFill>
-                  <a:srgbClr val="E88B1A"/>
-                </a:solidFill>
-              </a:rPr>
-              <a:t>DUELO RELÂMPAGO</a:t>
-            </a:r>
-          </a:p>
-        </p:txBody>
-      </p:sp>
-      <p:sp>
-        <p:nvSpPr>
-          <p:cNvPr id="4" name="TextBox 3"/>
-          <p:cNvSpPr txBox="1"/>
-          <p:nvPr/>
-        </p:nvSpPr>
-        <p:spPr>
-          <a:xfrm>
-            <a:off x="640080" y="685800"/>
-            <a:ext cx="10881360" cy="822960"/>
-          </a:xfrm>
-          <a:prstGeom prst="rect">
-            <a:avLst/>
-          </a:prstGeom>
-          <a:noFill/>
-        </p:spPr>
-        <p:txBody>
-          <a:bodyPr wrap="square" lIns="0" rIns="0" tIns="0" bIns="0" anchor="t">
-            <a:spAutoFit/>
-          </a:bodyPr>
-          <a:lstStyle/>
-          <a:p>
-            <a:pPr algn="l"/>
-            <a:r>
-              <a:rPr sz="3400" b="1" i="0">
-                <a:solidFill>
-                  <a:srgbClr val="0B5C5C"/>
-                </a:solidFill>
-              </a:rPr>
-              <a:t>Time A × Time B</a:t>
-            </a:r>
-          </a:p>
-        </p:txBody>
-      </p:sp>
-      <p:sp>
-        <p:nvSpPr>
-          <p:cNvPr id="5" name="Rectangle 4"/>
-          <p:cNvSpPr/>
-          <p:nvPr/>
-        </p:nvSpPr>
-        <p:spPr>
-          <a:xfrm>
-            <a:off x="640080" y="1554480"/>
-            <a:ext cx="10881360" cy="54864"/>
-          </a:xfrm>
-          <a:prstGeom prst="rect">
-            <a:avLst/>
-          </a:prstGeom>
-          <a:solidFill>
-            <a:srgbClr val="0B5C5C"/>
-          </a:solidFill>
-          <a:ln>
-            <a:noFill/>
-          </a:ln>
-        </p:spPr>
-        <p:style>
-          <a:lnRef idx="1">
-            <a:schemeClr val="accent1"/>
-          </a:lnRef>
-          <a:fillRef idx="3">
-            <a:schemeClr val="accent1"/>
-          </a:fillRef>
-          <a:effectRef idx="2">
-            <a:schemeClr val="accent1"/>
-          </a:effectRef>
-          <a:fontRef idx="minor">
-            <a:schemeClr val="lt1"/>
-          </a:fontRef>
-        </p:style>
-        <p:txBody>
-          <a:bodyPr rtlCol="0" anchor="ctr"/>
-          <a:lstStyle/>
-          <a:p>
-            <a:pPr algn="ctr"/>
-          </a:p>
-        </p:txBody>
-      </p:sp>
-      <p:sp>
-        <p:nvSpPr>
-          <p:cNvPr id="6" name="TextBox 5"/>
-          <p:cNvSpPr txBox="1"/>
-          <p:nvPr/>
-        </p:nvSpPr>
-        <p:spPr>
-          <a:xfrm>
-            <a:off x="640080" y="2560320"/>
-            <a:ext cx="10881360" cy="3474720"/>
-          </a:xfrm>
-          <a:prstGeom prst="rect">
-            <a:avLst/>
-          </a:prstGeom>
-          <a:noFill/>
-        </p:spPr>
-        <p:txBody>
-          <a:bodyPr wrap="square" lIns="0" rIns="0" tIns="0" bIns="0" anchor="t">
-            <a:spAutoFit/>
-          </a:bodyPr>
-          <a:lstStyle/>
-          <a:p>
-            <a:pPr algn="l"/>
-            <a:r>
-              <a:rPr sz="2400" b="0" i="0">
-                <a:solidFill>
-                  <a:srgbClr val="1A1A1A"/>
-                </a:solidFill>
-              </a:rPr>
-              <a:t>•  5 segundos pra responder</a:t>
-            </a:r>
-          </a:p>
-          <a:p>
-            <a:pPr algn="l"/>
-            <a:r>
-              <a:rPr sz="2400" b="0" i="0">
-                <a:solidFill>
-                  <a:srgbClr val="1A1A1A"/>
-                </a:solidFill>
-              </a:rPr>
-              <a:t>•  Errou, passa pro outro time</a:t>
-            </a:r>
-          </a:p>
-          <a:p>
-            <a:pPr algn="l"/>
-            <a:r>
-              <a:rPr sz="2400" b="0" i="0">
-                <a:solidFill>
-                  <a:srgbClr val="1A1A1A"/>
-                </a:solidFill>
-              </a:rPr>
-              <a:t>•  Vale ponto quem explicar o porquê</a:t>
-            </a:r>
-          </a:p>
-        </p:txBody>
-      </p:sp>
-      <p:sp>
-        <p:nvSpPr>
-          <p:cNvPr id="7" name="TextBox 6"/>
-          <p:cNvSpPr txBox="1"/>
-          <p:nvPr/>
-        </p:nvSpPr>
-        <p:spPr>
-          <a:xfrm>
-            <a:off x="640080" y="6446520"/>
-            <a:ext cx="10881360" cy="274320"/>
-          </a:xfrm>
-          <a:prstGeom prst="rect">
-            <a:avLst/>
-          </a:prstGeom>
-          <a:noFill/>
-        </p:spPr>
-        <p:txBody>
-          <a:bodyPr wrap="square" lIns="0" rIns="0" tIns="0" bIns="0" anchor="t">
-            <a:spAutoFit/>
-          </a:bodyPr>
-          <a:lstStyle/>
-          <a:p>
-            <a:pPr algn="l"/>
-            <a:r>
-              <a:rPr sz="1000" b="0" i="1">
-                <a:solidFill>
-                  <a:srgbClr val="555555"/>
-                </a:solidFill>
-              </a:rPr>
-              <a:t>Redes de Computadores · Noite 6</a:t>
-            </a:r>
-          </a:p>
-        </p:txBody>
-      </p:sp>
-    </p:spTree>
-  </p:cSld>
-  <p:clrMapOvr>
-    <a:masterClrMapping/>
-  </p:clrMapOvr>
-</p:sld>
-</file>
-
-<file path=ppt/slides/slide27.xml><?xml version="1.0" encoding="utf-8"?>
-<p:sld xmlns:a="http://schemas.openxmlformats.org/drawingml/2006/main" xmlns:p="http://schemas.openxmlformats.org/presentationml/2006/main" xmlns:r="http://schemas.openxmlformats.org/officeDocument/2006/relationships">
-  <p:cSld>
-    <p:spTree>
-      <p:nvGrpSpPr>
-        <p:cNvPr id="1" name=""/>
-        <p:cNvGrpSpPr/>
-        <p:nvPr/>
-      </p:nvGrpSpPr>
-      <p:grpSpPr/>
-      <p:sp>
-        <p:nvSpPr>
-          <p:cNvPr id="2" name="Rectangle 1"/>
-          <p:cNvSpPr/>
-          <p:nvPr/>
-        </p:nvSpPr>
-        <p:spPr>
-          <a:xfrm>
-            <a:off x="0" y="0"/>
-            <a:ext cx="12191695" cy="6858000"/>
-          </a:xfrm>
-          <a:prstGeom prst="rect">
-            <a:avLst/>
-          </a:prstGeom>
-          <a:solidFill>
-            <a:srgbClr val="F4F7F7"/>
-          </a:solidFill>
-          <a:ln>
-            <a:noFill/>
-          </a:ln>
-        </p:spPr>
-        <p:style>
-          <a:lnRef idx="1">
-            <a:schemeClr val="accent1"/>
-          </a:lnRef>
-          <a:fillRef idx="3">
-            <a:schemeClr val="accent1"/>
-          </a:fillRef>
-          <a:effectRef idx="2">
-            <a:schemeClr val="accent1"/>
-          </a:effectRef>
-          <a:fontRef idx="minor">
-            <a:schemeClr val="lt1"/>
-          </a:fontRef>
-        </p:style>
-        <p:txBody>
-          <a:bodyPr rtlCol="0" anchor="ctr"/>
-          <a:lstStyle/>
-          <a:p>
-            <a:pPr algn="ctr"/>
-          </a:p>
-        </p:txBody>
-      </p:sp>
-      <p:sp>
-        <p:nvSpPr>
-          <p:cNvPr id="3" name="TextBox 2"/>
-          <p:cNvSpPr txBox="1"/>
-          <p:nvPr/>
-        </p:nvSpPr>
-        <p:spPr>
-          <a:xfrm>
-            <a:off x="640080" y="365760"/>
-            <a:ext cx="10881360" cy="320040"/>
-          </a:xfrm>
-          <a:prstGeom prst="rect">
-            <a:avLst/>
-          </a:prstGeom>
-          <a:noFill/>
-        </p:spPr>
-        <p:txBody>
-          <a:bodyPr wrap="square" lIns="0" rIns="0" tIns="0" bIns="0" anchor="t">
-            <a:spAutoFit/>
-          </a:bodyPr>
-          <a:lstStyle/>
-          <a:p>
-            <a:pPr algn="l"/>
-            <a:r>
-              <a:rPr sz="1300" b="1" i="0">
-                <a:solidFill>
-                  <a:srgbClr val="E88B1A"/>
-                </a:solidFill>
-              </a:rPr>
-              <a:t>O QUE FICA</a:t>
-            </a:r>
-          </a:p>
-        </p:txBody>
-      </p:sp>
-      <p:sp>
-        <p:nvSpPr>
-          <p:cNvPr id="4" name="TextBox 3"/>
-          <p:cNvSpPr txBox="1"/>
-          <p:nvPr/>
-        </p:nvSpPr>
-        <p:spPr>
-          <a:xfrm>
-            <a:off x="640080" y="685800"/>
-            <a:ext cx="10881360" cy="822960"/>
-          </a:xfrm>
-          <a:prstGeom prst="rect">
-            <a:avLst/>
-          </a:prstGeom>
-          <a:noFill/>
-        </p:spPr>
-        <p:txBody>
-          <a:bodyPr wrap="square" lIns="0" rIns="0" tIns="0" bIns="0" anchor="t">
-            <a:spAutoFit/>
-          </a:bodyPr>
-          <a:lstStyle/>
-          <a:p>
-            <a:pPr algn="l"/>
-            <a:r>
-              <a:rPr sz="3400" b="1" i="0">
-                <a:solidFill>
-                  <a:srgbClr val="0B5C5C"/>
-                </a:solidFill>
-              </a:rPr>
-              <a:t>Três frases pra guardar</a:t>
-            </a:r>
-          </a:p>
-        </p:txBody>
-      </p:sp>
-      <p:sp>
-        <p:nvSpPr>
-          <p:cNvPr id="5" name="Rectangle 4"/>
-          <p:cNvSpPr/>
-          <p:nvPr/>
-        </p:nvSpPr>
-        <p:spPr>
-          <a:xfrm>
-            <a:off x="640080" y="1554480"/>
-            <a:ext cx="10881360" cy="54864"/>
-          </a:xfrm>
-          <a:prstGeom prst="rect">
-            <a:avLst/>
-          </a:prstGeom>
-          <a:solidFill>
-            <a:srgbClr val="0B5C5C"/>
-          </a:solidFill>
-          <a:ln>
-            <a:noFill/>
-          </a:ln>
-        </p:spPr>
-        <p:style>
-          <a:lnRef idx="1">
-            <a:schemeClr val="accent1"/>
-          </a:lnRef>
-          <a:fillRef idx="3">
-            <a:schemeClr val="accent1"/>
-          </a:fillRef>
-          <a:effectRef idx="2">
-            <a:schemeClr val="accent1"/>
-          </a:effectRef>
-          <a:fontRef idx="minor">
-            <a:schemeClr val="lt1"/>
-          </a:fontRef>
-        </p:style>
-        <p:txBody>
-          <a:bodyPr rtlCol="0" anchor="ctr"/>
-          <a:lstStyle/>
-          <a:p>
-            <a:pPr algn="ctr"/>
-          </a:p>
-        </p:txBody>
-      </p:sp>
-      <p:sp>
-        <p:nvSpPr>
-          <p:cNvPr id="6" name="TextBox 5"/>
-          <p:cNvSpPr txBox="1"/>
-          <p:nvPr/>
-        </p:nvSpPr>
-        <p:spPr>
-          <a:xfrm>
-            <a:off x="640080" y="2560320"/>
-            <a:ext cx="10881360" cy="3474720"/>
-          </a:xfrm>
-          <a:prstGeom prst="rect">
-            <a:avLst/>
-          </a:prstGeom>
-          <a:noFill/>
-        </p:spPr>
-        <p:txBody>
-          <a:bodyPr wrap="square" lIns="0" rIns="0" tIns="0" bIns="0" anchor="t">
-            <a:spAutoFit/>
-          </a:bodyPr>
-          <a:lstStyle/>
-          <a:p>
-            <a:pPr algn="l"/>
-            <a:r>
-              <a:rPr sz="2400" b="0" i="0">
-                <a:solidFill>
-                  <a:srgbClr val="1A1A1A"/>
-                </a:solidFill>
-              </a:rPr>
-              <a:t>"MAC é o CPF. IP é o número do apartamento."</a:t>
-            </a:r>
-          </a:p>
-          <a:p>
-            <a:pPr algn="l"/>
-            <a:r>
-              <a:rPr sz="2400" b="0" i="0">
-                <a:solidFill>
-                  <a:srgbClr val="1A1A1A"/>
-                </a:solidFill>
-              </a:rPr>
-              <a:t/>
-            </a:r>
-          </a:p>
-          <a:p>
-            <a:pPr algn="l"/>
-            <a:r>
-              <a:rPr sz="2400" b="0" i="0">
-                <a:solidFill>
-                  <a:srgbClr val="1A1A1A"/>
-                </a:solidFill>
-              </a:rPr>
-              <a:t>"169.254: ninguém deu endereço."</a:t>
-            </a:r>
-          </a:p>
-          <a:p>
-            <a:pPr algn="l"/>
-            <a:r>
-              <a:rPr sz="2400" b="0" i="0">
-                <a:solidFill>
-                  <a:srgbClr val="1A1A1A"/>
-                </a:solidFill>
-              </a:rPr>
-              <a:t/>
-            </a:r>
-          </a:p>
-          <a:p>
-            <a:pPr algn="l"/>
-            <a:r>
-              <a:rPr sz="2400" b="0" i="0">
-                <a:solidFill>
-                  <a:srgbClr val="1A1A1A"/>
-                </a:solidFill>
-              </a:rPr>
-              <a:t>"Quem está na rede? Pergunte ao roteador."</a:t>
-            </a:r>
-          </a:p>
-        </p:txBody>
-      </p:sp>
-      <p:sp>
-        <p:nvSpPr>
-          <p:cNvPr id="7" name="TextBox 6"/>
-          <p:cNvSpPr txBox="1"/>
-          <p:nvPr/>
-        </p:nvSpPr>
-        <p:spPr>
-          <a:xfrm>
-            <a:off x="640080" y="6446520"/>
-            <a:ext cx="10881360" cy="274320"/>
-          </a:xfrm>
-          <a:prstGeom prst="rect">
-            <a:avLst/>
-          </a:prstGeom>
-          <a:noFill/>
-        </p:spPr>
-        <p:txBody>
-          <a:bodyPr wrap="square" lIns="0" rIns="0" tIns="0" bIns="0" anchor="t">
-            <a:spAutoFit/>
-          </a:bodyPr>
-          <a:lstStyle/>
-          <a:p>
-            <a:pPr algn="l"/>
-            <a:r>
-              <a:rPr sz="1000" b="0" i="1">
-                <a:solidFill>
-                  <a:srgbClr val="555555"/>
-                </a:solidFill>
-              </a:rPr>
-              <a:t>Redes de Computadores · Noite 6</a:t>
-            </a:r>
-          </a:p>
-        </p:txBody>
-      </p:sp>
-    </p:spTree>
-  </p:cSld>
-  <p:clrMapOvr>
-    <a:masterClrMapping/>
-  </p:clrMapOvr>
-</p:sld>
-</file>
-
 <file path=ppt/slides/slide28.xml><?xml version="1.0" encoding="utf-8"?>
 <p:sld xmlns:a="http://schemas.openxmlformats.org/drawingml/2006/main" xmlns:p="http://schemas.openxmlformats.org/presentationml/2006/main" xmlns:r="http://schemas.openxmlformats.org/officeDocument/2006/relationships">
   <p:cSld>
@@ -8799,7 +8979,7 @@
                   <a:srgbClr val="E88B1A"/>
                 </a:solidFill>
               </a:rPr>
-              <a:t>PARA A PRÓXIMA NOITE</a:t>
+              <a:t>PRÁTICA · 25 MIN</a:t>
             </a:r>
           </a:p>
         </p:txBody>
@@ -8833,7 +9013,7 @@
                   <a:srgbClr val="0B5C5C"/>
                 </a:solidFill>
               </a:rPr>
-              <a:t>Nomes na rede: DNS e HTTPS</a:t>
+              <a:t>O cartaz da rede</a:t>
             </a:r>
           </a:p>
         </p:txBody>
@@ -8905,56 +9085,374 @@
           <a:p>
             <a:pPr algn="l"/>
             <a:r>
-              <a:rPr sz="2000" b="0" i="0">
+              <a:rPr sz="1800" b="0" i="0">
                 <a:solidFill>
                   <a:srgbClr val="1A1A1A"/>
                 </a:solidFill>
               </a:rPr>
-              <a:t>Uma tarefa simples:</a:t>
-            </a:r>
-          </a:p>
-          <a:p>
-            <a:pPr algn="l"/>
-            <a:r>
-              <a:rPr sz="2000" b="0" i="0">
+              <a:t>•  No meio: o roteador — modelo, MAC da etiqueta, portaria</a:t>
+            </a:r>
+          </a:p>
+          <a:p>
+            <a:pPr algn="l"/>
+            <a:r>
+              <a:rPr sz="1800" b="0" i="0">
                 <a:solidFill>
                   <a:srgbClr val="1A1A1A"/>
                 </a:solidFill>
               </a:rPr>
+              <a:t>•  Em volta: cada aparelho — dono, nome na lista, IP, MAC (★ = aleatório)</a:t>
+            </a:r>
+          </a:p>
+          <a:p>
+            <a:pPr algn="l"/>
+            <a:r>
+              <a:rPr sz="1800" b="0" i="0">
+                <a:solidFill>
+                  <a:srgbClr val="1A1A1A"/>
+                </a:solidFill>
+              </a:rPr>
+              <a:t>•  Em vermelho: o intruso (ou quem poderia ter entrado)</a:t>
+            </a:r>
+          </a:p>
+          <a:p>
+            <a:pPr algn="l"/>
+            <a:r>
+              <a:rPr sz="1800" b="0" i="0">
+                <a:solidFill>
+                  <a:srgbClr val="1A1A1A"/>
+                </a:solidFill>
+              </a:rPr>
+              <a:t>•  Em verde, fora do prédio: a rua e o IP de fora</a:t>
+            </a:r>
+          </a:p>
+          <a:p>
+            <a:pPr algn="l"/>
+            <a:r>
+              <a:rPr sz="1800" b="0" i="0">
+                <a:solidFill>
+                  <a:srgbClr val="1A1A1A"/>
+                </a:solidFill>
+              </a:rPr>
+              <a:t>•  Num canto: quando essa rede ficaria com 169.254?</a:t>
+            </a:r>
+          </a:p>
+        </p:txBody>
+      </p:sp>
+      <p:sp>
+        <p:nvSpPr>
+          <p:cNvPr id="7" name="TextBox 6"/>
+          <p:cNvSpPr txBox="1"/>
+          <p:nvPr/>
+        </p:nvSpPr>
+        <p:spPr>
+          <a:xfrm>
+            <a:off x="640080" y="5852160"/>
+            <a:ext cx="10881360" cy="457200"/>
+          </a:xfrm>
+          <a:prstGeom prst="rect">
+            <a:avLst/>
+          </a:prstGeom>
+          <a:noFill/>
+        </p:spPr>
+        <p:txBody>
+          <a:bodyPr wrap="square" lIns="0" rIns="0" tIns="0" bIns="0" anchor="t">
+            <a:spAutoFit/>
+          </a:bodyPr>
+          <a:lstStyle/>
+          <a:p>
+            <a:pPr algn="ctr"/>
+            <a:r>
+              <a:rPr sz="1600" b="0" i="1">
+                <a:solidFill>
+                  <a:srgbClr val="E88B1A"/>
+                </a:solidFill>
+              </a:rPr>
+              <a:t>Depois: cada equipe apresenta. Todo mundo fala uma parte.</a:t>
+            </a:r>
+          </a:p>
+        </p:txBody>
+      </p:sp>
+      <p:sp>
+        <p:nvSpPr>
+          <p:cNvPr id="8" name="TextBox 7"/>
+          <p:cNvSpPr txBox="1"/>
+          <p:nvPr/>
+        </p:nvSpPr>
+        <p:spPr>
+          <a:xfrm>
+            <a:off x="640080" y="6446520"/>
+            <a:ext cx="10881360" cy="274320"/>
+          </a:xfrm>
+          <a:prstGeom prst="rect">
+            <a:avLst/>
+          </a:prstGeom>
+          <a:noFill/>
+        </p:spPr>
+        <p:txBody>
+          <a:bodyPr wrap="square" lIns="0" rIns="0" tIns="0" bIns="0" anchor="t">
+            <a:spAutoFit/>
+          </a:bodyPr>
+          <a:lstStyle/>
+          <a:p>
+            <a:pPr algn="l"/>
+            <a:r>
+              <a:rPr sz="1000" b="0" i="1">
+                <a:solidFill>
+                  <a:srgbClr val="555555"/>
+                </a:solidFill>
+              </a:rPr>
+              <a:t>Redes de Computadores · Noite 6</a:t>
+            </a:r>
+          </a:p>
+        </p:txBody>
+      </p:sp>
+    </p:spTree>
+  </p:cSld>
+  <p:clrMapOvr>
+    <a:masterClrMapping/>
+  </p:clrMapOvr>
+</p:sld>
+</file>
+
+<file path=ppt/slides/slide29.xml><?xml version="1.0" encoding="utf-8"?>
+<p:sld xmlns:a="http://schemas.openxmlformats.org/drawingml/2006/main" xmlns:p="http://schemas.openxmlformats.org/presentationml/2006/main" xmlns:r="http://schemas.openxmlformats.org/officeDocument/2006/relationships">
+  <p:cSld>
+    <p:spTree>
+      <p:nvGrpSpPr>
+        <p:cNvPr id="1" name=""/>
+        <p:cNvGrpSpPr/>
+        <p:nvPr/>
+      </p:nvGrpSpPr>
+      <p:grpSpPr/>
+      <p:sp>
+        <p:nvSpPr>
+          <p:cNvPr id="2" name="Rectangle 1"/>
+          <p:cNvSpPr/>
+          <p:nvPr/>
+        </p:nvSpPr>
+        <p:spPr>
+          <a:xfrm>
+            <a:off x="0" y="0"/>
+            <a:ext cx="12191695" cy="6858000"/>
+          </a:xfrm>
+          <a:prstGeom prst="rect">
+            <a:avLst/>
+          </a:prstGeom>
+          <a:solidFill>
+            <a:srgbClr val="F4F7F7"/>
+          </a:solidFill>
+          <a:ln>
+            <a:noFill/>
+          </a:ln>
+        </p:spPr>
+        <p:style>
+          <a:lnRef idx="1">
+            <a:schemeClr val="accent1"/>
+          </a:lnRef>
+          <a:fillRef idx="3">
+            <a:schemeClr val="accent1"/>
+          </a:fillRef>
+          <a:effectRef idx="2">
+            <a:schemeClr val="accent1"/>
+          </a:effectRef>
+          <a:fontRef idx="minor">
+            <a:schemeClr val="lt1"/>
+          </a:fontRef>
+        </p:style>
+        <p:txBody>
+          <a:bodyPr rtlCol="0" anchor="ctr"/>
+          <a:lstStyle/>
+          <a:p>
+            <a:pPr algn="ctr"/>
+          </a:p>
+        </p:txBody>
+      </p:sp>
+      <p:sp>
+        <p:nvSpPr>
+          <p:cNvPr id="3" name="TextBox 2"/>
+          <p:cNvSpPr txBox="1"/>
+          <p:nvPr/>
+        </p:nvSpPr>
+        <p:spPr>
+          <a:xfrm>
+            <a:off x="640080" y="365760"/>
+            <a:ext cx="10881360" cy="320040"/>
+          </a:xfrm>
+          <a:prstGeom prst="rect">
+            <a:avLst/>
+          </a:prstGeom>
+          <a:noFill/>
+        </p:spPr>
+        <p:txBody>
+          <a:bodyPr wrap="square" lIns="0" rIns="0" tIns="0" bIns="0" anchor="t">
+            <a:spAutoFit/>
+          </a:bodyPr>
+          <a:lstStyle/>
+          <a:p>
+            <a:pPr algn="l"/>
+            <a:r>
+              <a:rPr sz="1300" b="1" i="0">
+                <a:solidFill>
+                  <a:srgbClr val="E88B1A"/>
+                </a:solidFill>
+              </a:rPr>
+              <a:t>O QUE FICA</a:t>
+            </a:r>
+          </a:p>
+        </p:txBody>
+      </p:sp>
+      <p:sp>
+        <p:nvSpPr>
+          <p:cNvPr id="4" name="TextBox 3"/>
+          <p:cNvSpPr txBox="1"/>
+          <p:nvPr/>
+        </p:nvSpPr>
+        <p:spPr>
+          <a:xfrm>
+            <a:off x="640080" y="685800"/>
+            <a:ext cx="10881360" cy="822960"/>
+          </a:xfrm>
+          <a:prstGeom prst="rect">
+            <a:avLst/>
+          </a:prstGeom>
+          <a:noFill/>
+        </p:spPr>
+        <p:txBody>
+          <a:bodyPr wrap="square" lIns="0" rIns="0" tIns="0" bIns="0" anchor="t">
+            <a:spAutoFit/>
+          </a:bodyPr>
+          <a:lstStyle/>
+          <a:p>
+            <a:pPr algn="l"/>
+            <a:r>
+              <a:rPr sz="3400" b="1" i="0">
+                <a:solidFill>
+                  <a:srgbClr val="0B5C5C"/>
+                </a:solidFill>
+              </a:rPr>
+              <a:t>Três frases pra guardar</a:t>
+            </a:r>
+          </a:p>
+        </p:txBody>
+      </p:sp>
+      <p:sp>
+        <p:nvSpPr>
+          <p:cNvPr id="5" name="Rectangle 4"/>
+          <p:cNvSpPr/>
+          <p:nvPr/>
+        </p:nvSpPr>
+        <p:spPr>
+          <a:xfrm>
+            <a:off x="640080" y="1554480"/>
+            <a:ext cx="10881360" cy="54864"/>
+          </a:xfrm>
+          <a:prstGeom prst="rect">
+            <a:avLst/>
+          </a:prstGeom>
+          <a:solidFill>
+            <a:srgbClr val="0B5C5C"/>
+          </a:solidFill>
+          <a:ln>
+            <a:noFill/>
+          </a:ln>
+        </p:spPr>
+        <p:style>
+          <a:lnRef idx="1">
+            <a:schemeClr val="accent1"/>
+          </a:lnRef>
+          <a:fillRef idx="3">
+            <a:schemeClr val="accent1"/>
+          </a:fillRef>
+          <a:effectRef idx="2">
+            <a:schemeClr val="accent1"/>
+          </a:effectRef>
+          <a:fontRef idx="minor">
+            <a:schemeClr val="lt1"/>
+          </a:fontRef>
+        </p:style>
+        <p:txBody>
+          <a:bodyPr rtlCol="0" anchor="ctr"/>
+          <a:lstStyle/>
+          <a:p>
+            <a:pPr algn="ctr"/>
+          </a:p>
+        </p:txBody>
+      </p:sp>
+      <p:sp>
+        <p:nvSpPr>
+          <p:cNvPr id="6" name="TextBox 5"/>
+          <p:cNvSpPr txBox="1"/>
+          <p:nvPr/>
+        </p:nvSpPr>
+        <p:spPr>
+          <a:xfrm>
+            <a:off x="640080" y="2560320"/>
+            <a:ext cx="10881360" cy="3474720"/>
+          </a:xfrm>
+          <a:prstGeom prst="rect">
+            <a:avLst/>
+          </a:prstGeom>
+          <a:noFill/>
+        </p:spPr>
+        <p:txBody>
+          <a:bodyPr wrap="square" lIns="0" rIns="0" tIns="0" bIns="0" anchor="t">
+            <a:spAutoFit/>
+          </a:bodyPr>
+          <a:lstStyle/>
+          <a:p>
+            <a:pPr algn="l"/>
+            <a:r>
+              <a:rPr sz="2400" b="0" i="0">
+                <a:solidFill>
+                  <a:srgbClr val="1A1A1A"/>
+                </a:solidFill>
+              </a:rPr>
+              <a:t>"MAC é o CPF. IP é o número do apartamento."</a:t>
+            </a:r>
+          </a:p>
+          <a:p>
+            <a:pPr algn="l"/>
+            <a:r>
+              <a:rPr sz="2400" b="0" i="0">
+                <a:solidFill>
+                  <a:srgbClr val="1A1A1A"/>
+                </a:solidFill>
+              </a:rPr>
               <a:t/>
             </a:r>
           </a:p>
           <a:p>
             <a:pPr algn="l"/>
             <a:r>
-              <a:rPr sz="2000" b="0" i="0">
+              <a:rPr sz="2400" b="0" i="0">
                 <a:solidFill>
                   <a:srgbClr val="1A1A1A"/>
                 </a:solidFill>
               </a:rPr>
-              <a:t>•  Abra três sites que você usa no celular</a:t>
-            </a:r>
-          </a:p>
-          <a:p>
-            <a:pPr algn="l"/>
-            <a:r>
-              <a:rPr sz="2000" b="0" i="0">
+              <a:t>"169.254: ninguém deu endereço."</a:t>
+            </a:r>
+          </a:p>
+          <a:p>
+            <a:pPr algn="l"/>
+            <a:r>
+              <a:rPr sz="2400" b="0" i="0">
                 <a:solidFill>
                   <a:srgbClr val="1A1A1A"/>
                 </a:solidFill>
               </a:rPr>
-              <a:t>•  Anote o endereço completo da barra — com o https://</a:t>
-            </a:r>
-          </a:p>
-          <a:p>
-            <a:pPr algn="l"/>
-            <a:r>
-              <a:rPr sz="2000" b="0" i="0">
+              <a:t/>
+            </a:r>
+          </a:p>
+          <a:p>
+            <a:pPr algn="l"/>
+            <a:r>
+              <a:rPr sz="2400" b="0" i="0">
                 <a:solidFill>
                   <a:srgbClr val="1A1A1A"/>
                 </a:solidFill>
               </a:rPr>
-              <a:t>•  Repare: tem cadeado?</a:t>
+              <a:t>"Quem está na rede? Pergunte ao roteador."</a:t>
             </a:r>
           </a:p>
         </p:txBody>
@@ -9250,6 +9748,290 @@
                 </a:solidFill>
               </a:rPr>
               <a:t>•  E os MACs, tem algum igual?</a:t>
+            </a:r>
+          </a:p>
+        </p:txBody>
+      </p:sp>
+      <p:sp>
+        <p:nvSpPr>
+          <p:cNvPr id="7" name="TextBox 6"/>
+          <p:cNvSpPr txBox="1"/>
+          <p:nvPr/>
+        </p:nvSpPr>
+        <p:spPr>
+          <a:xfrm>
+            <a:off x="640080" y="6446520"/>
+            <a:ext cx="10881360" cy="274320"/>
+          </a:xfrm>
+          <a:prstGeom prst="rect">
+            <a:avLst/>
+          </a:prstGeom>
+          <a:noFill/>
+        </p:spPr>
+        <p:txBody>
+          <a:bodyPr wrap="square" lIns="0" rIns="0" tIns="0" bIns="0" anchor="t">
+            <a:spAutoFit/>
+          </a:bodyPr>
+          <a:lstStyle/>
+          <a:p>
+            <a:pPr algn="l"/>
+            <a:r>
+              <a:rPr sz="1000" b="0" i="1">
+                <a:solidFill>
+                  <a:srgbClr val="555555"/>
+                </a:solidFill>
+              </a:rPr>
+              <a:t>Redes de Computadores · Noite 6</a:t>
+            </a:r>
+          </a:p>
+        </p:txBody>
+      </p:sp>
+    </p:spTree>
+  </p:cSld>
+  <p:clrMapOvr>
+    <a:masterClrMapping/>
+  </p:clrMapOvr>
+</p:sld>
+</file>
+
+<file path=ppt/slides/slide30.xml><?xml version="1.0" encoding="utf-8"?>
+<p:sld xmlns:a="http://schemas.openxmlformats.org/drawingml/2006/main" xmlns:p="http://schemas.openxmlformats.org/presentationml/2006/main" xmlns:r="http://schemas.openxmlformats.org/officeDocument/2006/relationships">
+  <p:cSld>
+    <p:spTree>
+      <p:nvGrpSpPr>
+        <p:cNvPr id="1" name=""/>
+        <p:cNvGrpSpPr/>
+        <p:nvPr/>
+      </p:nvGrpSpPr>
+      <p:grpSpPr/>
+      <p:sp>
+        <p:nvSpPr>
+          <p:cNvPr id="2" name="Rectangle 1"/>
+          <p:cNvSpPr/>
+          <p:nvPr/>
+        </p:nvSpPr>
+        <p:spPr>
+          <a:xfrm>
+            <a:off x="0" y="0"/>
+            <a:ext cx="12191695" cy="6858000"/>
+          </a:xfrm>
+          <a:prstGeom prst="rect">
+            <a:avLst/>
+          </a:prstGeom>
+          <a:solidFill>
+            <a:srgbClr val="F4F7F7"/>
+          </a:solidFill>
+          <a:ln>
+            <a:noFill/>
+          </a:ln>
+        </p:spPr>
+        <p:style>
+          <a:lnRef idx="1">
+            <a:schemeClr val="accent1"/>
+          </a:lnRef>
+          <a:fillRef idx="3">
+            <a:schemeClr val="accent1"/>
+          </a:fillRef>
+          <a:effectRef idx="2">
+            <a:schemeClr val="accent1"/>
+          </a:effectRef>
+          <a:fontRef idx="minor">
+            <a:schemeClr val="lt1"/>
+          </a:fontRef>
+        </p:style>
+        <p:txBody>
+          <a:bodyPr rtlCol="0" anchor="ctr"/>
+          <a:lstStyle/>
+          <a:p>
+            <a:pPr algn="ctr"/>
+          </a:p>
+        </p:txBody>
+      </p:sp>
+      <p:sp>
+        <p:nvSpPr>
+          <p:cNvPr id="3" name="TextBox 2"/>
+          <p:cNvSpPr txBox="1"/>
+          <p:nvPr/>
+        </p:nvSpPr>
+        <p:spPr>
+          <a:xfrm>
+            <a:off x="640080" y="365760"/>
+            <a:ext cx="10881360" cy="320040"/>
+          </a:xfrm>
+          <a:prstGeom prst="rect">
+            <a:avLst/>
+          </a:prstGeom>
+          <a:noFill/>
+        </p:spPr>
+        <p:txBody>
+          <a:bodyPr wrap="square" lIns="0" rIns="0" tIns="0" bIns="0" anchor="t">
+            <a:spAutoFit/>
+          </a:bodyPr>
+          <a:lstStyle/>
+          <a:p>
+            <a:pPr algn="l"/>
+            <a:r>
+              <a:rPr sz="1300" b="1" i="0">
+                <a:solidFill>
+                  <a:srgbClr val="E88B1A"/>
+                </a:solidFill>
+              </a:rPr>
+              <a:t>PARA A PRÓXIMA NOITE</a:t>
+            </a:r>
+          </a:p>
+        </p:txBody>
+      </p:sp>
+      <p:sp>
+        <p:nvSpPr>
+          <p:cNvPr id="4" name="TextBox 3"/>
+          <p:cNvSpPr txBox="1"/>
+          <p:nvPr/>
+        </p:nvSpPr>
+        <p:spPr>
+          <a:xfrm>
+            <a:off x="640080" y="685800"/>
+            <a:ext cx="10881360" cy="822960"/>
+          </a:xfrm>
+          <a:prstGeom prst="rect">
+            <a:avLst/>
+          </a:prstGeom>
+          <a:noFill/>
+        </p:spPr>
+        <p:txBody>
+          <a:bodyPr wrap="square" lIns="0" rIns="0" tIns="0" bIns="0" anchor="t">
+            <a:spAutoFit/>
+          </a:bodyPr>
+          <a:lstStyle/>
+          <a:p>
+            <a:pPr algn="l"/>
+            <a:r>
+              <a:rPr sz="3400" b="1" i="0">
+                <a:solidFill>
+                  <a:srgbClr val="0B5C5C"/>
+                </a:solidFill>
+              </a:rPr>
+              <a:t>Nomes na rede: DNS e HTTPS</a:t>
+            </a:r>
+          </a:p>
+        </p:txBody>
+      </p:sp>
+      <p:sp>
+        <p:nvSpPr>
+          <p:cNvPr id="5" name="Rectangle 4"/>
+          <p:cNvSpPr/>
+          <p:nvPr/>
+        </p:nvSpPr>
+        <p:spPr>
+          <a:xfrm>
+            <a:off x="640080" y="1554480"/>
+            <a:ext cx="10881360" cy="54864"/>
+          </a:xfrm>
+          <a:prstGeom prst="rect">
+            <a:avLst/>
+          </a:prstGeom>
+          <a:solidFill>
+            <a:srgbClr val="0B5C5C"/>
+          </a:solidFill>
+          <a:ln>
+            <a:noFill/>
+          </a:ln>
+        </p:spPr>
+        <p:style>
+          <a:lnRef idx="1">
+            <a:schemeClr val="accent1"/>
+          </a:lnRef>
+          <a:fillRef idx="3">
+            <a:schemeClr val="accent1"/>
+          </a:fillRef>
+          <a:effectRef idx="2">
+            <a:schemeClr val="accent1"/>
+          </a:effectRef>
+          <a:fontRef idx="minor">
+            <a:schemeClr val="lt1"/>
+          </a:fontRef>
+        </p:style>
+        <p:txBody>
+          <a:bodyPr rtlCol="0" anchor="ctr"/>
+          <a:lstStyle/>
+          <a:p>
+            <a:pPr algn="ctr"/>
+          </a:p>
+        </p:txBody>
+      </p:sp>
+      <p:sp>
+        <p:nvSpPr>
+          <p:cNvPr id="6" name="TextBox 5"/>
+          <p:cNvSpPr txBox="1"/>
+          <p:nvPr/>
+        </p:nvSpPr>
+        <p:spPr>
+          <a:xfrm>
+            <a:off x="640080" y="2560320"/>
+            <a:ext cx="10881360" cy="3474720"/>
+          </a:xfrm>
+          <a:prstGeom prst="rect">
+            <a:avLst/>
+          </a:prstGeom>
+          <a:noFill/>
+        </p:spPr>
+        <p:txBody>
+          <a:bodyPr wrap="square" lIns="0" rIns="0" tIns="0" bIns="0" anchor="t">
+            <a:spAutoFit/>
+          </a:bodyPr>
+          <a:lstStyle/>
+          <a:p>
+            <a:pPr algn="l"/>
+            <a:r>
+              <a:rPr sz="2000" b="0" i="0">
+                <a:solidFill>
+                  <a:srgbClr val="1A1A1A"/>
+                </a:solidFill>
+              </a:rPr>
+              <a:t>Uma tarefa simples:</a:t>
+            </a:r>
+          </a:p>
+          <a:p>
+            <a:pPr algn="l"/>
+            <a:r>
+              <a:rPr sz="2000" b="0" i="0">
+                <a:solidFill>
+                  <a:srgbClr val="1A1A1A"/>
+                </a:solidFill>
+              </a:rPr>
+              <a:t/>
+            </a:r>
+          </a:p>
+          <a:p>
+            <a:pPr algn="l"/>
+            <a:r>
+              <a:rPr sz="2000" b="0" i="0">
+                <a:solidFill>
+                  <a:srgbClr val="1A1A1A"/>
+                </a:solidFill>
+              </a:rPr>
+              <a:t>•  Abra três sites que você usa no celular</a:t>
+            </a:r>
+          </a:p>
+          <a:p>
+            <a:pPr algn="l"/>
+            <a:r>
+              <a:rPr sz="2000" b="0" i="0">
+                <a:solidFill>
+                  <a:srgbClr val="1A1A1A"/>
+                </a:solidFill>
+              </a:rPr>
+              <a:t>•  Anote o endereço completo da barra — com o https://</a:t>
+            </a:r>
+          </a:p>
+          <a:p>
+            <a:pPr algn="l"/>
+            <a:r>
+              <a:rPr sz="2000" b="0" i="0">
+                <a:solidFill>
+                  <a:srgbClr val="1A1A1A"/>
+                </a:solidFill>
+              </a:rPr>
+              <a:t>•  Repare: tem cadeado?</a:t>
             </a:r>
           </a:p>
         </p:txBody>

</xml_diff>